<commit_message>
sync: 4/27 마무리 — figure_1 재생성 + Conclusion 슬라이드 + References + 임채림 석사 + RQ3 ID 1~7
- ↔ → "vs" 일괄 변경 (이모지 렌더링 방지)
- RQ3 ID (A)(B)(C)(E)(F)(G)(H) → 1~7 번호 (보고서 표 3 + 발표 S12)
- figure_1 (Phase 4 scatter) matplotlib 2×2 격자 재생성 (X축 겹침 해소, 통계박스 폰트 10pt)
- Conclusion 슬라이드 (S16) 신설 — 4 핵심 발견 카드 + 인용
- About Team 4-step 카드 (S15) 강화 — 각자 highlight
- 보고서 §6 References section 신설 (8 건: Exqutor / Cohen / Horvitz-Thompson / Neyman / Wilcoxon / Indyk-Motwani / JL / Acharya)
- 임채림 석사 표기 정정 (이채림 → 임채림 전수)
- S6 Two-Level figure 제거 (텍스트 박스 충돌 해소, S11 에 큰 사이즈로 표시)
- S8 layout 재구성 (좌 표 + 우 figure 정사각)
- 4 라운드 딥리뷰 통과 (CRITICAL 0, HIGH 11 모두 해소)
- 다음 세션 프롬프트 작성 (_internal/next_session_prompt.md)

다음 세션 (4/28 마감 직전): 울트라리뷰 + figure A 등급 재생성 (figure_9/10/2/6) + 최종 LearnUs 업로드

Co-Authored-By: Claude Opus 4.7 (1M context) <noreply@anthropic.com>
</commit_message>
<xml_diff>
--- a/submission/_drafts/속도는벡터_중간발표.pptx
+++ b/submission/_drafts/속도는벡터_중간발표.pptx
@@ -21,6 +21,7 @@
     <p:sldId id="269" r:id="rId20"/>
     <p:sldId id="270" r:id="rId21"/>
     <p:sldId id="271" r:id="rId22"/>
+    <p:sldId id="272" r:id="rId23"/>
   </p:sldIdLst>
   <p:sldSz cx="12191695" cy="6858000" type="screen4x3"/>
   <p:notesSz cx="6858000" cy="9144000"/>
@@ -3803,7 +3804,7 @@
                 <a:ea typeface="Apple SD Gothic Neo"/>
                 <a:cs typeface="Apple SD Gothic Neo"/>
               </a:rPr>
-              <a:t>10 / 16</a:t>
+              <a:t>10 / 17</a:t>
             </a:r>
           </a:p>
         </p:txBody>
@@ -4595,7 +4596,7 @@
                 <a:ea typeface="Apple SD Gothic Neo"/>
                 <a:cs typeface="Apple SD Gothic Neo"/>
               </a:rPr>
-              <a:t>①  DEEP 1M ↔ 8M : CI 겹침 (CONSISTENT) — 8 배 규모에서 동일 효과 재현</a:t>
+              <a:t>①  DEEP 1M vs 8M : CI 겹침 (CONSISTENT) — 8 배 규모에서 동일 효과 재현</a:t>
             </a:r>
           </a:p>
           <a:p>
@@ -4874,7 +4875,7 @@
                 <a:ea typeface="Apple SD Gothic Neo"/>
                 <a:cs typeface="Apple SD Gothic Neo"/>
               </a:rPr>
-              <a:t>11 / 16</a:t>
+              <a:t>11 / 17</a:t>
             </a:r>
           </a:p>
         </p:txBody>
@@ -6331,7 +6332,7 @@
                 <a:ea typeface="Apple SD Gothic Neo"/>
                 <a:cs typeface="Apple SD Gothic Neo"/>
               </a:rPr>
-              <a:t>12 / 16</a:t>
+              <a:t>12 / 17</a:t>
             </a:r>
           </a:p>
         </p:txBody>
@@ -6677,7 +6678,7 @@
                 <a:ea typeface="Apple SD Gothic Neo"/>
                 <a:cs typeface="Apple SD Gothic Neo"/>
               </a:rPr>
-              <a:t>A. LSH Random Hyperplane</a:t>
+              <a:t>1. LSH Random Hyperplane</a:t>
             </a:r>
           </a:p>
         </p:txBody>
@@ -6762,7 +6763,7 @@
                 <a:ea typeface="Apple SD Gothic Neo"/>
                 <a:cs typeface="Apple SD Gothic Neo"/>
               </a:rPr>
-              <a:t>C. Random Projection (JL)</a:t>
+              <a:t>2. Random Projection (JL)</a:t>
             </a:r>
           </a:p>
         </p:txBody>
@@ -6847,7 +6848,7 @@
                 <a:ea typeface="Apple SD Gothic Neo"/>
                 <a:cs typeface="Apple SD Gothic Neo"/>
               </a:rPr>
-              <a:t>E. Hilbert Curve</a:t>
+              <a:t>3. Hilbert Curve</a:t>
             </a:r>
           </a:p>
         </p:txBody>
@@ -6932,7 +6933,7 @@
                 <a:ea typeface="Apple SD Gothic Neo"/>
                 <a:cs typeface="Apple SD Gothic Neo"/>
               </a:rPr>
-              <a:t>F. Mini-batch K-means</a:t>
+              <a:t>4. Mini-batch K-means</a:t>
             </a:r>
           </a:p>
         </p:txBody>
@@ -7232,7 +7233,7 @@
                 <a:ea typeface="Apple SD Gothic Neo"/>
                 <a:cs typeface="Apple SD Gothic Neo"/>
               </a:rPr>
-              <a:t>G. Distance-Shell</a:t>
+              <a:t>5. Distance-Shell</a:t>
             </a:r>
           </a:p>
         </p:txBody>
@@ -7317,7 +7318,7 @@
                 <a:ea typeface="Apple SD Gothic Neo"/>
                 <a:cs typeface="Apple SD Gothic Neo"/>
               </a:rPr>
-              <a:t>B. KDE-pilot (Neyman)</a:t>
+              <a:t>6. KDE-pilot (Neyman)</a:t>
             </a:r>
           </a:p>
         </p:txBody>
@@ -7617,7 +7618,7 @@
                 <a:ea typeface="Apple SD Gothic Neo"/>
                 <a:cs typeface="Apple SD Gothic Neo"/>
               </a:rPr>
-              <a:t>H. Importance Sampling</a:t>
+              <a:t>7. Importance Sampling</a:t>
             </a:r>
           </a:p>
         </p:txBody>
@@ -8023,7 +8024,7 @@
                 <a:ea typeface="Apple SD Gothic Neo"/>
                 <a:cs typeface="Apple SD Gothic Neo"/>
               </a:rPr>
-              <a:t>13 / 16</a:t>
+              <a:t>13 / 17</a:t>
             </a:r>
           </a:p>
         </p:txBody>
@@ -9740,7 +9741,7 @@
                 <a:ea typeface="Apple SD Gothic Neo"/>
                 <a:cs typeface="Apple SD Gothic Neo"/>
               </a:rPr>
-              <a:t>14 / 16</a:t>
+              <a:t>14 / 17</a:t>
             </a:r>
           </a:p>
         </p:txBody>
@@ -11542,402 +11543,1916 @@
                 <a:ea typeface="Apple SD Gothic Neo"/>
                 <a:cs typeface="Apple SD Gothic Neo"/>
               </a:rPr>
-              <a:t>15 / 16</a:t>
-            </a:r>
-          </a:p>
-        </p:txBody>
-      </p:sp>
-      <p:graphicFrame>
-        <p:nvGraphicFramePr>
-          <p:cNvPr id="6" name="Table 5"/>
-          <p:cNvGraphicFramePr>
-            <a:graphicFrameLocks noGrp="1"/>
-          </p:cNvGraphicFramePr>
-          <p:nvPr/>
-        </p:nvGraphicFramePr>
-        <p:xfrm>
-          <a:off x="548640" y="1508760"/>
-          <a:ext cx="11064240" cy="3200400"/>
-        </p:xfrm>
-        <a:graphic>
-          <a:graphicData uri="http://schemas.openxmlformats.org/drawingml/2006/table">
-            <a:tbl>
-              <a:tblPr firstRow="1" bandRow="1">
-                <a:tableStyleId>{5C22544A-7EE6-4342-B048-85BDC9FD1C3A}</a:tableStyleId>
-              </a:tblPr>
-              <a:tblGrid>
-                <a:gridCol w="1371600"/>
-                <a:gridCol w="1645920"/>
-                <a:gridCol w="8046720"/>
-              </a:tblGrid>
-              <a:tr h="640080">
-                <a:tc>
-                  <a:txBody>
-                    <a:bodyPr/>
-                    <a:lstStyle/>
-                    <a:p>
-                      <a:pPr algn="l"/>
-                      <a:r>
-                        <a:rPr sz="1200" b="1">
-                          <a:solidFill>
-                            <a:srgbClr val="FFFFFF"/>
-                          </a:solidFill>
-                          <a:latin typeface="Apple SD Gothic Neo"/>
-                        </a:rPr>
-                        <a:t>이름</a:t>
-                      </a:r>
-                    </a:p>
-                  </a:txBody>
-                  <a:tcPr>
-                    <a:solidFill>
-                      <a:srgbClr val="2563EB"/>
-                    </a:solidFill>
-                  </a:tcPr>
-                </a:tc>
-                <a:tc>
-                  <a:txBody>
-                    <a:bodyPr/>
-                    <a:lstStyle/>
-                    <a:p>
-                      <a:pPr algn="l"/>
-                      <a:r>
-                        <a:rPr sz="1200" b="1">
-                          <a:solidFill>
-                            <a:srgbClr val="FFFFFF"/>
-                          </a:solidFill>
-                          <a:latin typeface="Apple SD Gothic Neo"/>
-                        </a:rPr>
-                        <a:t>역할</a:t>
-                      </a:r>
-                    </a:p>
-                  </a:txBody>
-                  <a:tcPr>
-                    <a:solidFill>
-                      <a:srgbClr val="2563EB"/>
-                    </a:solidFill>
-                  </a:tcPr>
-                </a:tc>
-                <a:tc>
-                  <a:txBody>
-                    <a:bodyPr/>
-                    <a:lstStyle/>
-                    <a:p>
-                      <a:pPr algn="l"/>
-                      <a:r>
-                        <a:rPr sz="1200" b="1">
-                          <a:solidFill>
-                            <a:srgbClr val="FFFFFF"/>
-                          </a:solidFill>
-                          <a:latin typeface="Apple SD Gothic Neo"/>
-                        </a:rPr>
-                        <a:t>담당</a:t>
-                      </a:r>
-                    </a:p>
-                  </a:txBody>
-                  <a:tcPr>
-                    <a:solidFill>
-                      <a:srgbClr val="2563EB"/>
-                    </a:solidFill>
-                  </a:tcPr>
-                </a:tc>
-              </a:tr>
-              <a:tr h="640080">
-                <a:tc>
-                  <a:txBody>
-                    <a:bodyPr/>
-                    <a:lstStyle/>
-                    <a:p>
-                      <a:pPr algn="l"/>
-                      <a:r>
-                        <a:rPr sz="1100" b="1">
-                          <a:solidFill>
-                            <a:srgbClr val="0F172A"/>
-                          </a:solidFill>
-                          <a:latin typeface="Apple SD Gothic Neo"/>
-                        </a:rPr>
-                        <a:t>박세은</a:t>
-                      </a:r>
-                    </a:p>
-                  </a:txBody>
-                  <a:tcPr>
-                    <a:solidFill>
-                      <a:srgbClr val="F8FAFC"/>
-                    </a:solidFill>
-                  </a:tcPr>
-                </a:tc>
-                <a:tc>
-                  <a:txBody>
-                    <a:bodyPr/>
-                    <a:lstStyle/>
-                    <a:p>
-                      <a:pPr algn="l"/>
-                      <a:r>
-                        <a:rPr sz="1100" b="1">
-                          <a:solidFill>
-                            <a:srgbClr val="0F172A"/>
-                          </a:solidFill>
-                          <a:latin typeface="Apple SD Gothic Neo"/>
-                        </a:rPr>
-                        <a:t>팀장</a:t>
-                      </a:r>
-                    </a:p>
-                  </a:txBody>
-                  <a:tcPr>
-                    <a:solidFill>
-                      <a:srgbClr val="F8FAFC"/>
-                    </a:solidFill>
-                  </a:tcPr>
-                </a:tc>
-                <a:tc>
-                  <a:txBody>
-                    <a:bodyPr/>
-                    <a:lstStyle/>
-                    <a:p>
-                      <a:pPr algn="l"/>
-                      <a:r>
-                        <a:rPr sz="1100" b="0">
-                          <a:solidFill>
-                            <a:srgbClr val="0F172A"/>
-                          </a:solidFill>
-                          <a:latin typeface="Apple SD Gothic Neo"/>
-                        </a:rPr>
-                        <a:t>전체 일정 관리 · 자문 회신 정리 · 발표·보고서 총괄</a:t>
-                      </a:r>
-                    </a:p>
-                  </a:txBody>
-                  <a:tcPr>
-                    <a:solidFill>
-                      <a:srgbClr val="F8FAFC"/>
-                    </a:solidFill>
-                  </a:tcPr>
-                </a:tc>
-              </a:tr>
-              <a:tr h="640080">
-                <a:tc>
-                  <a:txBody>
-                    <a:bodyPr/>
-                    <a:lstStyle/>
-                    <a:p>
-                      <a:pPr algn="l"/>
-                      <a:r>
-                        <a:rPr sz="1100" b="1">
-                          <a:solidFill>
-                            <a:srgbClr val="0F172A"/>
-                          </a:solidFill>
-                          <a:latin typeface="Apple SD Gothic Neo"/>
-                        </a:rPr>
-                        <a:t>강재현</a:t>
-                      </a:r>
-                    </a:p>
-                  </a:txBody>
-                  <a:tcPr>
-                    <a:solidFill>
-                      <a:srgbClr val="FFFFFF"/>
-                    </a:solidFill>
-                  </a:tcPr>
-                </a:tc>
-                <a:tc>
-                  <a:txBody>
-                    <a:bodyPr/>
-                    <a:lstStyle/>
-                    <a:p>
-                      <a:pPr algn="l"/>
-                      <a:r>
-                        <a:rPr sz="1100" b="1">
-                          <a:solidFill>
-                            <a:srgbClr val="0F172A"/>
-                          </a:solidFill>
-                          <a:latin typeface="Apple SD Gothic Neo"/>
-                        </a:rPr>
-                        <a:t>주 발표자</a:t>
-                      </a:r>
-                    </a:p>
-                  </a:txBody>
-                  <a:tcPr>
-                    <a:solidFill>
-                      <a:srgbClr val="FFFFFF"/>
-                    </a:solidFill>
-                  </a:tcPr>
-                </a:tc>
-                <a:tc>
-                  <a:txBody>
-                    <a:bodyPr/>
-                    <a:lstStyle/>
-                    <a:p>
-                      <a:pPr algn="l"/>
-                      <a:r>
-                        <a:rPr sz="1100" b="0">
-                          <a:solidFill>
-                            <a:srgbClr val="0F172A"/>
-                          </a:solidFill>
-                          <a:latin typeface="Apple SD Gothic Neo"/>
-                        </a:rPr>
-                        <a:t>중간발표 주 발표 · 슬라이드 검수 · Q&amp;A 사회</a:t>
-                      </a:r>
-                    </a:p>
-                  </a:txBody>
-                  <a:tcPr>
-                    <a:solidFill>
-                      <a:srgbClr val="FFFFFF"/>
-                    </a:solidFill>
-                  </a:tcPr>
-                </a:tc>
-              </a:tr>
-              <a:tr h="640080">
-                <a:tc>
-                  <a:txBody>
-                    <a:bodyPr/>
-                    <a:lstStyle/>
-                    <a:p>
-                      <a:pPr algn="l"/>
-                      <a:r>
-                        <a:rPr sz="1100" b="1">
-                          <a:solidFill>
-                            <a:srgbClr val="0F172A"/>
-                          </a:solidFill>
-                          <a:latin typeface="Apple SD Gothic Neo"/>
-                        </a:rPr>
-                        <a:t>조현빈</a:t>
-                      </a:r>
-                    </a:p>
-                  </a:txBody>
-                  <a:tcPr>
-                    <a:solidFill>
-                      <a:srgbClr val="F8FAFC"/>
-                    </a:solidFill>
-                  </a:tcPr>
-                </a:tc>
-                <a:tc>
-                  <a:txBody>
-                    <a:bodyPr/>
-                    <a:lstStyle/>
-                    <a:p>
-                      <a:pPr algn="l"/>
-                      <a:r>
-                        <a:rPr sz="1100" b="1">
-                          <a:solidFill>
-                            <a:srgbClr val="0F172A"/>
-                          </a:solidFill>
-                          <a:latin typeface="Apple SD Gothic Neo"/>
-                        </a:rPr>
-                        <a:t>실험·문서화</a:t>
-                      </a:r>
-                    </a:p>
-                  </a:txBody>
-                  <a:tcPr>
-                    <a:solidFill>
-                      <a:srgbClr val="F8FAFC"/>
-                    </a:solidFill>
-                  </a:tcPr>
-                </a:tc>
-                <a:tc>
-                  <a:txBody>
-                    <a:bodyPr/>
-                    <a:lstStyle/>
-                    <a:p>
-                      <a:pPr algn="l"/>
-                      <a:r>
-                        <a:rPr sz="1100" b="0">
-                          <a:solidFill>
-                            <a:srgbClr val="0F172A"/>
-                          </a:solidFill>
-                          <a:latin typeface="Apple SD Gothic Neo"/>
-                        </a:rPr>
-                        <a:t>RQ1/RQ2 실험 · vector.c native 구현 · 보고서 작성</a:t>
-                      </a:r>
-                    </a:p>
-                  </a:txBody>
-                  <a:tcPr>
-                    <a:solidFill>
-                      <a:srgbClr val="F8FAFC"/>
-                    </a:solidFill>
-                  </a:tcPr>
-                </a:tc>
-              </a:tr>
-              <a:tr h="640080">
-                <a:tc>
-                  <a:txBody>
-                    <a:bodyPr/>
-                    <a:lstStyle/>
-                    <a:p>
-                      <a:pPr algn="l"/>
-                      <a:r>
-                        <a:rPr sz="1100" b="1">
-                          <a:solidFill>
-                            <a:srgbClr val="0F172A"/>
-                          </a:solidFill>
-                          <a:latin typeface="Apple SD Gothic Neo"/>
-                        </a:rPr>
-                        <a:t>이동욱</a:t>
-                      </a:r>
-                    </a:p>
-                  </a:txBody>
-                  <a:tcPr>
-                    <a:solidFill>
-                      <a:srgbClr val="FFFFFF"/>
-                    </a:solidFill>
-                  </a:tcPr>
-                </a:tc>
-                <a:tc>
-                  <a:txBody>
-                    <a:bodyPr/>
-                    <a:lstStyle/>
-                    <a:p>
-                      <a:pPr algn="l"/>
-                      <a:r>
-                        <a:rPr sz="1100" b="1">
-                          <a:solidFill>
-                            <a:srgbClr val="0F172A"/>
-                          </a:solidFill>
-                          <a:latin typeface="Apple SD Gothic Neo"/>
-                        </a:rPr>
-                        <a:t>분석·작도</a:t>
-                      </a:r>
-                    </a:p>
-                  </a:txBody>
-                  <a:tcPr>
-                    <a:solidFill>
-                      <a:srgbClr val="FFFFFF"/>
-                    </a:solidFill>
-                  </a:tcPr>
-                </a:tc>
-                <a:tc>
-                  <a:txBody>
-                    <a:bodyPr/>
-                    <a:lstStyle/>
-                    <a:p>
-                      <a:pPr algn="l"/>
-                      <a:r>
-                        <a:rPr sz="1100" b="0">
-                          <a:solidFill>
-                            <a:srgbClr val="0F172A"/>
-                          </a:solidFill>
-                          <a:latin typeface="Apple SD Gothic Neo"/>
-                        </a:rPr>
-                        <a:t>통계 분석 (CI · Two-Level) · 그림 작성 · RQ3 설계</a:t>
-                      </a:r>
-                    </a:p>
-                  </a:txBody>
-                  <a:tcPr>
-                    <a:solidFill>
-                      <a:srgbClr val="FFFFFF"/>
-                    </a:solidFill>
-                  </a:tcPr>
-                </a:tc>
-              </a:tr>
-            </a:tbl>
-          </a:graphicData>
-        </a:graphic>
-      </p:graphicFrame>
-      <p:sp>
-        <p:nvSpPr>
-          <p:cNvPr id="7" name="Rounded Rectangle 6"/>
+              <a:t>15 / 17</a:t>
+            </a:r>
+          </a:p>
+        </p:txBody>
+      </p:sp>
+      <p:sp>
+        <p:nvSpPr>
+          <p:cNvPr id="6" name="Rounded Rectangle 5"/>
           <p:cNvSpPr/>
           <p:nvPr/>
         </p:nvSpPr>
         <p:spPr>
           <a:xfrm>
-            <a:off x="548640" y="5486400"/>
+            <a:off x="548640" y="1463040"/>
+            <a:ext cx="2697480" cy="4023360"/>
+          </a:xfrm>
+          <a:prstGeom prst="roundRect">
+            <a:avLst>
+              <a:gd name="adj" fmla="val 8000"/>
+            </a:avLst>
+          </a:prstGeom>
+          <a:solidFill>
+            <a:srgbClr val="F8FAFC"/>
+          </a:solidFill>
+          <a:ln w="9525">
+            <a:solidFill>
+              <a:srgbClr val="E2E8F0"/>
+            </a:solidFill>
+          </a:ln>
+          <a:effectLst/>
+        </p:spPr>
+        <p:style>
+          <a:lnRef idx="1">
+            <a:schemeClr val="accent1"/>
+          </a:lnRef>
+          <a:fillRef idx="3">
+            <a:schemeClr val="accent1"/>
+          </a:fillRef>
+          <a:effectRef idx="2">
+            <a:schemeClr val="accent1"/>
+          </a:effectRef>
+          <a:fontRef idx="minor">
+            <a:schemeClr val="lt1"/>
+          </a:fontRef>
+        </p:style>
+        <p:txBody>
+          <a:bodyPr rtlCol="0" anchor="ctr"/>
+          <a:lstStyle/>
+          <a:p>
+            <a:pPr algn="ctr"/>
+          </a:p>
+        </p:txBody>
+      </p:sp>
+      <p:sp>
+        <p:nvSpPr>
+          <p:cNvPr id="7" name="Rectangle 6"/>
+          <p:cNvSpPr/>
+          <p:nvPr/>
+        </p:nvSpPr>
+        <p:spPr>
+          <a:xfrm>
+            <a:off x="548640" y="1463040"/>
+            <a:ext cx="2697480" cy="457200"/>
+          </a:xfrm>
+          <a:prstGeom prst="rect">
+            <a:avLst/>
+          </a:prstGeom>
+          <a:solidFill>
+            <a:srgbClr val="2563EB"/>
+          </a:solidFill>
+          <a:ln>
+            <a:noFill/>
+          </a:ln>
+          <a:effectLst/>
+        </p:spPr>
+        <p:style>
+          <a:lnRef idx="1">
+            <a:schemeClr val="accent1"/>
+          </a:lnRef>
+          <a:fillRef idx="3">
+            <a:schemeClr val="accent1"/>
+          </a:fillRef>
+          <a:effectRef idx="2">
+            <a:schemeClr val="accent1"/>
+          </a:effectRef>
+          <a:fontRef idx="minor">
+            <a:schemeClr val="lt1"/>
+          </a:fontRef>
+        </p:style>
+        <p:txBody>
+          <a:bodyPr rtlCol="0" anchor="ctr"/>
+          <a:lstStyle/>
+          <a:p>
+            <a:pPr algn="ctr"/>
+          </a:p>
+        </p:txBody>
+      </p:sp>
+      <p:sp>
+        <p:nvSpPr>
+          <p:cNvPr id="8" name="Oval 7"/>
+          <p:cNvSpPr/>
+          <p:nvPr/>
+        </p:nvSpPr>
+        <p:spPr>
+          <a:xfrm>
+            <a:off x="685800" y="1581912"/>
+            <a:ext cx="246888" cy="246888"/>
+          </a:xfrm>
+          <a:prstGeom prst="ellipse">
+            <a:avLst/>
+          </a:prstGeom>
+          <a:solidFill>
+            <a:srgbClr val="FFFFFF"/>
+          </a:solidFill>
+          <a:ln>
+            <a:noFill/>
+          </a:ln>
+          <a:effectLst/>
+        </p:spPr>
+        <p:style>
+          <a:lnRef idx="1">
+            <a:schemeClr val="accent1"/>
+          </a:lnRef>
+          <a:fillRef idx="3">
+            <a:schemeClr val="accent1"/>
+          </a:fillRef>
+          <a:effectRef idx="2">
+            <a:schemeClr val="accent1"/>
+          </a:effectRef>
+          <a:fontRef idx="minor">
+            <a:schemeClr val="lt1"/>
+          </a:fontRef>
+        </p:style>
+        <p:txBody>
+          <a:bodyPr rtlCol="0" anchor="ctr"/>
+          <a:lstStyle/>
+          <a:p>
+            <a:pPr algn="ctr"/>
+          </a:p>
+        </p:txBody>
+      </p:sp>
+      <p:sp>
+        <p:nvSpPr>
+          <p:cNvPr id="9" name="TextBox 8"/>
+          <p:cNvSpPr txBox="1"/>
+          <p:nvPr/>
+        </p:nvSpPr>
+        <p:spPr>
+          <a:xfrm>
+            <a:off x="685800" y="1581912"/>
+            <a:ext cx="246888" cy="246888"/>
+          </a:xfrm>
+          <a:prstGeom prst="rect">
+            <a:avLst/>
+          </a:prstGeom>
+          <a:noFill/>
+        </p:spPr>
+        <p:txBody>
+          <a:bodyPr wrap="square" lIns="45720" rIns="45720" tIns="18288" bIns="18288" anchor="t">
+            <a:spAutoFit/>
+          </a:bodyPr>
+          <a:lstStyle/>
+          <a:p>
+            <a:pPr algn="ctr">
+              <a:lnSpc>
+                <a:spcPct val="120000"/>
+              </a:lnSpc>
+            </a:pPr>
+            <a:r>
+              <a:rPr sz="1100" b="1">
+                <a:solidFill>
+                  <a:srgbClr val="2563EB"/>
+                </a:solidFill>
+                <a:latin typeface="Apple SD Gothic Neo"/>
+                <a:ea typeface="Apple SD Gothic Neo"/>
+                <a:cs typeface="Apple SD Gothic Neo"/>
+              </a:rPr>
+              <a:t>1</a:t>
+            </a:r>
+          </a:p>
+        </p:txBody>
+      </p:sp>
+      <p:sp>
+        <p:nvSpPr>
+          <p:cNvPr id="10" name="TextBox 9"/>
+          <p:cNvSpPr txBox="1"/>
+          <p:nvPr/>
+        </p:nvSpPr>
+        <p:spPr>
+          <a:xfrm>
+            <a:off x="1051560" y="1554480"/>
+            <a:ext cx="2103120" cy="292608"/>
+          </a:xfrm>
+          <a:prstGeom prst="rect">
+            <a:avLst/>
+          </a:prstGeom>
+          <a:noFill/>
+        </p:spPr>
+        <p:txBody>
+          <a:bodyPr wrap="square" lIns="45720" rIns="45720" tIns="18288" bIns="18288" anchor="t">
+            <a:spAutoFit/>
+          </a:bodyPr>
+          <a:lstStyle/>
+          <a:p>
+            <a:pPr algn="l">
+              <a:lnSpc>
+                <a:spcPct val="120000"/>
+              </a:lnSpc>
+            </a:pPr>
+            <a:r>
+              <a:rPr sz="1200" b="1">
+                <a:solidFill>
+                  <a:srgbClr val="FFFFFF"/>
+                </a:solidFill>
+                <a:latin typeface="Apple SD Gothic Neo"/>
+                <a:ea typeface="Apple SD Gothic Neo"/>
+                <a:cs typeface="Apple SD Gothic Neo"/>
+              </a:rPr>
+              <a:t>팀장</a:t>
+            </a:r>
+          </a:p>
+        </p:txBody>
+      </p:sp>
+      <p:sp>
+        <p:nvSpPr>
+          <p:cNvPr id="11" name="TextBox 10"/>
+          <p:cNvSpPr txBox="1"/>
+          <p:nvPr/>
+        </p:nvSpPr>
+        <p:spPr>
+          <a:xfrm>
+            <a:off x="731520" y="2057400"/>
+            <a:ext cx="2377440" cy="502920"/>
+          </a:xfrm>
+          <a:prstGeom prst="rect">
+            <a:avLst/>
+          </a:prstGeom>
+          <a:noFill/>
+        </p:spPr>
+        <p:txBody>
+          <a:bodyPr wrap="square" lIns="45720" rIns="45720" tIns="18288" bIns="18288" anchor="t">
+            <a:spAutoFit/>
+          </a:bodyPr>
+          <a:lstStyle/>
+          <a:p>
+            <a:pPr algn="l">
+              <a:lnSpc>
+                <a:spcPct val="120000"/>
+              </a:lnSpc>
+            </a:pPr>
+            <a:r>
+              <a:rPr sz="2200" b="1">
+                <a:solidFill>
+                  <a:srgbClr val="2563EB"/>
+                </a:solidFill>
+                <a:latin typeface="Apple SD Gothic Neo"/>
+                <a:ea typeface="Apple SD Gothic Neo"/>
+                <a:cs typeface="Apple SD Gothic Neo"/>
+              </a:rPr>
+              <a:t>박세은</a:t>
+            </a:r>
+          </a:p>
+        </p:txBody>
+      </p:sp>
+      <p:sp>
+        <p:nvSpPr>
+          <p:cNvPr id="12" name="Rectangle 11"/>
+          <p:cNvSpPr/>
+          <p:nvPr/>
+        </p:nvSpPr>
+        <p:spPr>
+          <a:xfrm>
+            <a:off x="731520" y="2651760"/>
+            <a:ext cx="1097280" cy="25400"/>
+          </a:xfrm>
+          <a:prstGeom prst="rect">
+            <a:avLst/>
+          </a:prstGeom>
+          <a:solidFill>
+            <a:srgbClr val="3B82F6"/>
+          </a:solidFill>
+          <a:ln>
+            <a:noFill/>
+          </a:ln>
+          <a:effectLst/>
+        </p:spPr>
+        <p:style>
+          <a:lnRef idx="1">
+            <a:schemeClr val="accent1"/>
+          </a:lnRef>
+          <a:fillRef idx="3">
+            <a:schemeClr val="accent1"/>
+          </a:fillRef>
+          <a:effectRef idx="2">
+            <a:schemeClr val="accent1"/>
+          </a:effectRef>
+          <a:fontRef idx="minor">
+            <a:schemeClr val="lt1"/>
+          </a:fontRef>
+        </p:style>
+        <p:txBody>
+          <a:bodyPr rtlCol="0" anchor="ctr"/>
+          <a:lstStyle/>
+          <a:p>
+            <a:pPr algn="ctr"/>
+          </a:p>
+        </p:txBody>
+      </p:sp>
+      <p:sp>
+        <p:nvSpPr>
+          <p:cNvPr id="13" name="TextBox 12"/>
+          <p:cNvSpPr txBox="1"/>
+          <p:nvPr/>
+        </p:nvSpPr>
+        <p:spPr>
+          <a:xfrm>
+            <a:off x="731520" y="2788920"/>
+            <a:ext cx="2377440" cy="1417320"/>
+          </a:xfrm>
+          <a:prstGeom prst="rect">
+            <a:avLst/>
+          </a:prstGeom>
+          <a:noFill/>
+        </p:spPr>
+        <p:txBody>
+          <a:bodyPr wrap="square" lIns="45720" rIns="45720" tIns="18288" bIns="18288" anchor="t">
+            <a:spAutoFit/>
+          </a:bodyPr>
+          <a:lstStyle/>
+          <a:p>
+            <a:pPr algn="l">
+              <a:lnSpc>
+                <a:spcPct val="140000"/>
+              </a:lnSpc>
+            </a:pPr>
+            <a:r>
+              <a:rPr sz="1000" b="0">
+                <a:solidFill>
+                  <a:srgbClr val="0F172A"/>
+                </a:solidFill>
+                <a:latin typeface="Apple SD Gothic Neo"/>
+                <a:ea typeface="Apple SD Gothic Neo"/>
+                <a:cs typeface="Apple SD Gothic Neo"/>
+              </a:rPr>
+              <a:t>전체 일정 관리 · 자문 회신 정리 · 발표·보고서 총괄</a:t>
+            </a:r>
+          </a:p>
+        </p:txBody>
+      </p:sp>
+      <p:sp>
+        <p:nvSpPr>
+          <p:cNvPr id="14" name="TextBox 13"/>
+          <p:cNvSpPr txBox="1"/>
+          <p:nvPr/>
+        </p:nvSpPr>
+        <p:spPr>
+          <a:xfrm>
+            <a:off x="731520" y="4343400"/>
+            <a:ext cx="2377440" cy="274320"/>
+          </a:xfrm>
+          <a:prstGeom prst="rect">
+            <a:avLst/>
+          </a:prstGeom>
+          <a:noFill/>
+        </p:spPr>
+        <p:txBody>
+          <a:bodyPr wrap="square" lIns="45720" rIns="45720" tIns="18288" bIns="18288" anchor="t">
+            <a:spAutoFit/>
+          </a:bodyPr>
+          <a:lstStyle/>
+          <a:p>
+            <a:pPr algn="l">
+              <a:lnSpc>
+                <a:spcPct val="120000"/>
+              </a:lnSpc>
+            </a:pPr>
+            <a:r>
+              <a:rPr sz="800" b="1">
+                <a:solidFill>
+                  <a:srgbClr val="3B82F6"/>
+                </a:solidFill>
+                <a:latin typeface="Apple SD Gothic Neo"/>
+                <a:ea typeface="Apple SD Gothic Neo"/>
+                <a:cs typeface="Apple SD Gothic Neo"/>
+              </a:rPr>
+              <a:t>HIGHLIGHT</a:t>
+            </a:r>
+          </a:p>
+        </p:txBody>
+      </p:sp>
+      <p:sp>
+        <p:nvSpPr>
+          <p:cNvPr id="15" name="Rounded Rectangle 14"/>
+          <p:cNvSpPr/>
+          <p:nvPr/>
+        </p:nvSpPr>
+        <p:spPr>
+          <a:xfrm>
+            <a:off x="731520" y="4617720"/>
+            <a:ext cx="2331720" cy="777240"/>
+          </a:xfrm>
+          <a:prstGeom prst="roundRect">
+            <a:avLst>
+              <a:gd name="adj" fmla="val 8000"/>
+            </a:avLst>
+          </a:prstGeom>
+          <a:solidFill>
+            <a:srgbClr val="FFFFFF"/>
+          </a:solidFill>
+          <a:ln w="9525">
+            <a:solidFill>
+              <a:srgbClr val="3B82F6"/>
+            </a:solidFill>
+          </a:ln>
+          <a:effectLst/>
+        </p:spPr>
+        <p:style>
+          <a:lnRef idx="1">
+            <a:schemeClr val="accent1"/>
+          </a:lnRef>
+          <a:fillRef idx="3">
+            <a:schemeClr val="accent1"/>
+          </a:fillRef>
+          <a:effectRef idx="2">
+            <a:schemeClr val="accent1"/>
+          </a:effectRef>
+          <a:fontRef idx="minor">
+            <a:schemeClr val="lt1"/>
+          </a:fontRef>
+        </p:style>
+        <p:txBody>
+          <a:bodyPr rtlCol="0" anchor="ctr"/>
+          <a:lstStyle/>
+          <a:p>
+            <a:pPr algn="ctr"/>
+          </a:p>
+        </p:txBody>
+      </p:sp>
+      <p:sp>
+        <p:nvSpPr>
+          <p:cNvPr id="16" name="TextBox 15"/>
+          <p:cNvSpPr txBox="1"/>
+          <p:nvPr/>
+        </p:nvSpPr>
+        <p:spPr>
+          <a:xfrm>
+            <a:off x="822960" y="4663440"/>
+            <a:ext cx="2194560" cy="685800"/>
+          </a:xfrm>
+          <a:prstGeom prst="rect">
+            <a:avLst/>
+          </a:prstGeom>
+          <a:noFill/>
+        </p:spPr>
+        <p:txBody>
+          <a:bodyPr wrap="square" lIns="45720" rIns="45720" tIns="18288" bIns="18288" anchor="t">
+            <a:spAutoFit/>
+          </a:bodyPr>
+          <a:lstStyle/>
+          <a:p>
+            <a:pPr algn="l">
+              <a:lnSpc>
+                <a:spcPct val="135000"/>
+              </a:lnSpc>
+            </a:pPr>
+            <a:r>
+              <a:rPr sz="1000" b="1">
+                <a:solidFill>
+                  <a:srgbClr val="0F172A"/>
+                </a:solidFill>
+                <a:latin typeface="Apple SD Gothic Neo"/>
+                <a:ea typeface="Apple SD Gothic Neo"/>
+                <a:cs typeface="Apple SD Gothic Neo"/>
+              </a:rPr>
+              <a:t>자문 컨택 정리 · 4 인 합의 주재</a:t>
+            </a:r>
+          </a:p>
+        </p:txBody>
+      </p:sp>
+      <p:sp>
+        <p:nvSpPr>
+          <p:cNvPr id="17" name="Rounded Rectangle 16"/>
+          <p:cNvSpPr/>
+          <p:nvPr/>
+        </p:nvSpPr>
+        <p:spPr>
+          <a:xfrm>
+            <a:off x="3337560" y="1463040"/>
+            <a:ext cx="2697480" cy="4023360"/>
+          </a:xfrm>
+          <a:prstGeom prst="roundRect">
+            <a:avLst>
+              <a:gd name="adj" fmla="val 8000"/>
+            </a:avLst>
+          </a:prstGeom>
+          <a:solidFill>
+            <a:srgbClr val="F8FAFC"/>
+          </a:solidFill>
+          <a:ln w="9525">
+            <a:solidFill>
+              <a:srgbClr val="E2E8F0"/>
+            </a:solidFill>
+          </a:ln>
+          <a:effectLst/>
+        </p:spPr>
+        <p:style>
+          <a:lnRef idx="1">
+            <a:schemeClr val="accent1"/>
+          </a:lnRef>
+          <a:fillRef idx="3">
+            <a:schemeClr val="accent1"/>
+          </a:fillRef>
+          <a:effectRef idx="2">
+            <a:schemeClr val="accent1"/>
+          </a:effectRef>
+          <a:fontRef idx="minor">
+            <a:schemeClr val="lt1"/>
+          </a:fontRef>
+        </p:style>
+        <p:txBody>
+          <a:bodyPr rtlCol="0" anchor="ctr"/>
+          <a:lstStyle/>
+          <a:p>
+            <a:pPr algn="ctr"/>
+          </a:p>
+        </p:txBody>
+      </p:sp>
+      <p:sp>
+        <p:nvSpPr>
+          <p:cNvPr id="18" name="Rectangle 17"/>
+          <p:cNvSpPr/>
+          <p:nvPr/>
+        </p:nvSpPr>
+        <p:spPr>
+          <a:xfrm>
+            <a:off x="3337560" y="1463040"/>
+            <a:ext cx="2697480" cy="457200"/>
+          </a:xfrm>
+          <a:prstGeom prst="rect">
+            <a:avLst/>
+          </a:prstGeom>
+          <a:solidFill>
+            <a:srgbClr val="2563EB"/>
+          </a:solidFill>
+          <a:ln>
+            <a:noFill/>
+          </a:ln>
+          <a:effectLst/>
+        </p:spPr>
+        <p:style>
+          <a:lnRef idx="1">
+            <a:schemeClr val="accent1"/>
+          </a:lnRef>
+          <a:fillRef idx="3">
+            <a:schemeClr val="accent1"/>
+          </a:fillRef>
+          <a:effectRef idx="2">
+            <a:schemeClr val="accent1"/>
+          </a:effectRef>
+          <a:fontRef idx="minor">
+            <a:schemeClr val="lt1"/>
+          </a:fontRef>
+        </p:style>
+        <p:txBody>
+          <a:bodyPr rtlCol="0" anchor="ctr"/>
+          <a:lstStyle/>
+          <a:p>
+            <a:pPr algn="ctr"/>
+          </a:p>
+        </p:txBody>
+      </p:sp>
+      <p:sp>
+        <p:nvSpPr>
+          <p:cNvPr id="19" name="Oval 18"/>
+          <p:cNvSpPr/>
+          <p:nvPr/>
+        </p:nvSpPr>
+        <p:spPr>
+          <a:xfrm>
+            <a:off x="3474720" y="1581912"/>
+            <a:ext cx="246888" cy="246888"/>
+          </a:xfrm>
+          <a:prstGeom prst="ellipse">
+            <a:avLst/>
+          </a:prstGeom>
+          <a:solidFill>
+            <a:srgbClr val="FFFFFF"/>
+          </a:solidFill>
+          <a:ln>
+            <a:noFill/>
+          </a:ln>
+          <a:effectLst/>
+        </p:spPr>
+        <p:style>
+          <a:lnRef idx="1">
+            <a:schemeClr val="accent1"/>
+          </a:lnRef>
+          <a:fillRef idx="3">
+            <a:schemeClr val="accent1"/>
+          </a:fillRef>
+          <a:effectRef idx="2">
+            <a:schemeClr val="accent1"/>
+          </a:effectRef>
+          <a:fontRef idx="minor">
+            <a:schemeClr val="lt1"/>
+          </a:fontRef>
+        </p:style>
+        <p:txBody>
+          <a:bodyPr rtlCol="0" anchor="ctr"/>
+          <a:lstStyle/>
+          <a:p>
+            <a:pPr algn="ctr"/>
+          </a:p>
+        </p:txBody>
+      </p:sp>
+      <p:sp>
+        <p:nvSpPr>
+          <p:cNvPr id="20" name="TextBox 19"/>
+          <p:cNvSpPr txBox="1"/>
+          <p:nvPr/>
+        </p:nvSpPr>
+        <p:spPr>
+          <a:xfrm>
+            <a:off x="3474720" y="1581912"/>
+            <a:ext cx="246888" cy="246888"/>
+          </a:xfrm>
+          <a:prstGeom prst="rect">
+            <a:avLst/>
+          </a:prstGeom>
+          <a:noFill/>
+        </p:spPr>
+        <p:txBody>
+          <a:bodyPr wrap="square" lIns="45720" rIns="45720" tIns="18288" bIns="18288" anchor="t">
+            <a:spAutoFit/>
+          </a:bodyPr>
+          <a:lstStyle/>
+          <a:p>
+            <a:pPr algn="ctr">
+              <a:lnSpc>
+                <a:spcPct val="120000"/>
+              </a:lnSpc>
+            </a:pPr>
+            <a:r>
+              <a:rPr sz="1100" b="1">
+                <a:solidFill>
+                  <a:srgbClr val="2563EB"/>
+                </a:solidFill>
+                <a:latin typeface="Apple SD Gothic Neo"/>
+                <a:ea typeface="Apple SD Gothic Neo"/>
+                <a:cs typeface="Apple SD Gothic Neo"/>
+              </a:rPr>
+              <a:t>2</a:t>
+            </a:r>
+          </a:p>
+        </p:txBody>
+      </p:sp>
+      <p:sp>
+        <p:nvSpPr>
+          <p:cNvPr id="21" name="TextBox 20"/>
+          <p:cNvSpPr txBox="1"/>
+          <p:nvPr/>
+        </p:nvSpPr>
+        <p:spPr>
+          <a:xfrm>
+            <a:off x="3840480" y="1554480"/>
+            <a:ext cx="2103120" cy="292608"/>
+          </a:xfrm>
+          <a:prstGeom prst="rect">
+            <a:avLst/>
+          </a:prstGeom>
+          <a:noFill/>
+        </p:spPr>
+        <p:txBody>
+          <a:bodyPr wrap="square" lIns="45720" rIns="45720" tIns="18288" bIns="18288" anchor="t">
+            <a:spAutoFit/>
+          </a:bodyPr>
+          <a:lstStyle/>
+          <a:p>
+            <a:pPr algn="l">
+              <a:lnSpc>
+                <a:spcPct val="120000"/>
+              </a:lnSpc>
+            </a:pPr>
+            <a:r>
+              <a:rPr sz="1200" b="1">
+                <a:solidFill>
+                  <a:srgbClr val="FFFFFF"/>
+                </a:solidFill>
+                <a:latin typeface="Apple SD Gothic Neo"/>
+                <a:ea typeface="Apple SD Gothic Neo"/>
+                <a:cs typeface="Apple SD Gothic Neo"/>
+              </a:rPr>
+              <a:t>주 발표자</a:t>
+            </a:r>
+          </a:p>
+        </p:txBody>
+      </p:sp>
+      <p:sp>
+        <p:nvSpPr>
+          <p:cNvPr id="22" name="TextBox 21"/>
+          <p:cNvSpPr txBox="1"/>
+          <p:nvPr/>
+        </p:nvSpPr>
+        <p:spPr>
+          <a:xfrm>
+            <a:off x="3520440" y="2057400"/>
+            <a:ext cx="2377440" cy="502920"/>
+          </a:xfrm>
+          <a:prstGeom prst="rect">
+            <a:avLst/>
+          </a:prstGeom>
+          <a:noFill/>
+        </p:spPr>
+        <p:txBody>
+          <a:bodyPr wrap="square" lIns="45720" rIns="45720" tIns="18288" bIns="18288" anchor="t">
+            <a:spAutoFit/>
+          </a:bodyPr>
+          <a:lstStyle/>
+          <a:p>
+            <a:pPr algn="l">
+              <a:lnSpc>
+                <a:spcPct val="120000"/>
+              </a:lnSpc>
+            </a:pPr>
+            <a:r>
+              <a:rPr sz="2200" b="1">
+                <a:solidFill>
+                  <a:srgbClr val="2563EB"/>
+                </a:solidFill>
+                <a:latin typeface="Apple SD Gothic Neo"/>
+                <a:ea typeface="Apple SD Gothic Neo"/>
+                <a:cs typeface="Apple SD Gothic Neo"/>
+              </a:rPr>
+              <a:t>강재현</a:t>
+            </a:r>
+          </a:p>
+        </p:txBody>
+      </p:sp>
+      <p:sp>
+        <p:nvSpPr>
+          <p:cNvPr id="23" name="Rectangle 22"/>
+          <p:cNvSpPr/>
+          <p:nvPr/>
+        </p:nvSpPr>
+        <p:spPr>
+          <a:xfrm>
+            <a:off x="3520440" y="2651760"/>
+            <a:ext cx="1097280" cy="25400"/>
+          </a:xfrm>
+          <a:prstGeom prst="rect">
+            <a:avLst/>
+          </a:prstGeom>
+          <a:solidFill>
+            <a:srgbClr val="3B82F6"/>
+          </a:solidFill>
+          <a:ln>
+            <a:noFill/>
+          </a:ln>
+          <a:effectLst/>
+        </p:spPr>
+        <p:style>
+          <a:lnRef idx="1">
+            <a:schemeClr val="accent1"/>
+          </a:lnRef>
+          <a:fillRef idx="3">
+            <a:schemeClr val="accent1"/>
+          </a:fillRef>
+          <a:effectRef idx="2">
+            <a:schemeClr val="accent1"/>
+          </a:effectRef>
+          <a:fontRef idx="minor">
+            <a:schemeClr val="lt1"/>
+          </a:fontRef>
+        </p:style>
+        <p:txBody>
+          <a:bodyPr rtlCol="0" anchor="ctr"/>
+          <a:lstStyle/>
+          <a:p>
+            <a:pPr algn="ctr"/>
+          </a:p>
+        </p:txBody>
+      </p:sp>
+      <p:sp>
+        <p:nvSpPr>
+          <p:cNvPr id="24" name="TextBox 23"/>
+          <p:cNvSpPr txBox="1"/>
+          <p:nvPr/>
+        </p:nvSpPr>
+        <p:spPr>
+          <a:xfrm>
+            <a:off x="3520440" y="2788920"/>
+            <a:ext cx="2377440" cy="1417320"/>
+          </a:xfrm>
+          <a:prstGeom prst="rect">
+            <a:avLst/>
+          </a:prstGeom>
+          <a:noFill/>
+        </p:spPr>
+        <p:txBody>
+          <a:bodyPr wrap="square" lIns="45720" rIns="45720" tIns="18288" bIns="18288" anchor="t">
+            <a:spAutoFit/>
+          </a:bodyPr>
+          <a:lstStyle/>
+          <a:p>
+            <a:pPr algn="l">
+              <a:lnSpc>
+                <a:spcPct val="140000"/>
+              </a:lnSpc>
+            </a:pPr>
+            <a:r>
+              <a:rPr sz="1000" b="0">
+                <a:solidFill>
+                  <a:srgbClr val="0F172A"/>
+                </a:solidFill>
+                <a:latin typeface="Apple SD Gothic Neo"/>
+                <a:ea typeface="Apple SD Gothic Neo"/>
+                <a:cs typeface="Apple SD Gothic Neo"/>
+              </a:rPr>
+              <a:t>중간발표 주 발표 · 슬라이드 검수 · Q&amp;A 사회</a:t>
+            </a:r>
+          </a:p>
+        </p:txBody>
+      </p:sp>
+      <p:sp>
+        <p:nvSpPr>
+          <p:cNvPr id="25" name="TextBox 24"/>
+          <p:cNvSpPr txBox="1"/>
+          <p:nvPr/>
+        </p:nvSpPr>
+        <p:spPr>
+          <a:xfrm>
+            <a:off x="3520440" y="4343400"/>
+            <a:ext cx="2377440" cy="274320"/>
+          </a:xfrm>
+          <a:prstGeom prst="rect">
+            <a:avLst/>
+          </a:prstGeom>
+          <a:noFill/>
+        </p:spPr>
+        <p:txBody>
+          <a:bodyPr wrap="square" lIns="45720" rIns="45720" tIns="18288" bIns="18288" anchor="t">
+            <a:spAutoFit/>
+          </a:bodyPr>
+          <a:lstStyle/>
+          <a:p>
+            <a:pPr algn="l">
+              <a:lnSpc>
+                <a:spcPct val="120000"/>
+              </a:lnSpc>
+            </a:pPr>
+            <a:r>
+              <a:rPr sz="800" b="1">
+                <a:solidFill>
+                  <a:srgbClr val="3B82F6"/>
+                </a:solidFill>
+                <a:latin typeface="Apple SD Gothic Neo"/>
+                <a:ea typeface="Apple SD Gothic Neo"/>
+                <a:cs typeface="Apple SD Gothic Neo"/>
+              </a:rPr>
+              <a:t>HIGHLIGHT</a:t>
+            </a:r>
+          </a:p>
+        </p:txBody>
+      </p:sp>
+      <p:sp>
+        <p:nvSpPr>
+          <p:cNvPr id="26" name="Rounded Rectangle 25"/>
+          <p:cNvSpPr/>
+          <p:nvPr/>
+        </p:nvSpPr>
+        <p:spPr>
+          <a:xfrm>
+            <a:off x="3520440" y="4617720"/>
+            <a:ext cx="2331720" cy="777240"/>
+          </a:xfrm>
+          <a:prstGeom prst="roundRect">
+            <a:avLst>
+              <a:gd name="adj" fmla="val 8000"/>
+            </a:avLst>
+          </a:prstGeom>
+          <a:solidFill>
+            <a:srgbClr val="FFFFFF"/>
+          </a:solidFill>
+          <a:ln w="9525">
+            <a:solidFill>
+              <a:srgbClr val="3B82F6"/>
+            </a:solidFill>
+          </a:ln>
+          <a:effectLst/>
+        </p:spPr>
+        <p:style>
+          <a:lnRef idx="1">
+            <a:schemeClr val="accent1"/>
+          </a:lnRef>
+          <a:fillRef idx="3">
+            <a:schemeClr val="accent1"/>
+          </a:fillRef>
+          <a:effectRef idx="2">
+            <a:schemeClr val="accent1"/>
+          </a:effectRef>
+          <a:fontRef idx="minor">
+            <a:schemeClr val="lt1"/>
+          </a:fontRef>
+        </p:style>
+        <p:txBody>
+          <a:bodyPr rtlCol="0" anchor="ctr"/>
+          <a:lstStyle/>
+          <a:p>
+            <a:pPr algn="ctr"/>
+          </a:p>
+        </p:txBody>
+      </p:sp>
+      <p:sp>
+        <p:nvSpPr>
+          <p:cNvPr id="27" name="TextBox 26"/>
+          <p:cNvSpPr txBox="1"/>
+          <p:nvPr/>
+        </p:nvSpPr>
+        <p:spPr>
+          <a:xfrm>
+            <a:off x="3611880" y="4663440"/>
+            <a:ext cx="2194560" cy="685800"/>
+          </a:xfrm>
+          <a:prstGeom prst="rect">
+            <a:avLst/>
+          </a:prstGeom>
+          <a:noFill/>
+        </p:spPr>
+        <p:txBody>
+          <a:bodyPr wrap="square" lIns="45720" rIns="45720" tIns="18288" bIns="18288" anchor="t">
+            <a:spAutoFit/>
+          </a:bodyPr>
+          <a:lstStyle/>
+          <a:p>
+            <a:pPr algn="l">
+              <a:lnSpc>
+                <a:spcPct val="135000"/>
+              </a:lnSpc>
+            </a:pPr>
+            <a:r>
+              <a:rPr sz="1000" b="1">
+                <a:solidFill>
+                  <a:srgbClr val="0F172A"/>
+                </a:solidFill>
+                <a:latin typeface="Apple SD Gothic Neo"/>
+                <a:ea typeface="Apple SD Gothic Neo"/>
+                <a:cs typeface="Apple SD Gothic Neo"/>
+              </a:rPr>
+              <a:t>16 슬라이드 검수 · 리허설 2회</a:t>
+            </a:r>
+          </a:p>
+        </p:txBody>
+      </p:sp>
+      <p:sp>
+        <p:nvSpPr>
+          <p:cNvPr id="28" name="Rounded Rectangle 27"/>
+          <p:cNvSpPr/>
+          <p:nvPr/>
+        </p:nvSpPr>
+        <p:spPr>
+          <a:xfrm>
+            <a:off x="6126479" y="1463040"/>
+            <a:ext cx="2697480" cy="4023360"/>
+          </a:xfrm>
+          <a:prstGeom prst="roundRect">
+            <a:avLst>
+              <a:gd name="adj" fmla="val 8000"/>
+            </a:avLst>
+          </a:prstGeom>
+          <a:solidFill>
+            <a:srgbClr val="F8FAFC"/>
+          </a:solidFill>
+          <a:ln w="9525">
+            <a:solidFill>
+              <a:srgbClr val="E2E8F0"/>
+            </a:solidFill>
+          </a:ln>
+          <a:effectLst/>
+        </p:spPr>
+        <p:style>
+          <a:lnRef idx="1">
+            <a:schemeClr val="accent1"/>
+          </a:lnRef>
+          <a:fillRef idx="3">
+            <a:schemeClr val="accent1"/>
+          </a:fillRef>
+          <a:effectRef idx="2">
+            <a:schemeClr val="accent1"/>
+          </a:effectRef>
+          <a:fontRef idx="minor">
+            <a:schemeClr val="lt1"/>
+          </a:fontRef>
+        </p:style>
+        <p:txBody>
+          <a:bodyPr rtlCol="0" anchor="ctr"/>
+          <a:lstStyle/>
+          <a:p>
+            <a:pPr algn="ctr"/>
+          </a:p>
+        </p:txBody>
+      </p:sp>
+      <p:sp>
+        <p:nvSpPr>
+          <p:cNvPr id="29" name="Rectangle 28"/>
+          <p:cNvSpPr/>
+          <p:nvPr/>
+        </p:nvSpPr>
+        <p:spPr>
+          <a:xfrm>
+            <a:off x="6126479" y="1463040"/>
+            <a:ext cx="2697480" cy="457200"/>
+          </a:xfrm>
+          <a:prstGeom prst="rect">
+            <a:avLst/>
+          </a:prstGeom>
+          <a:solidFill>
+            <a:srgbClr val="2563EB"/>
+          </a:solidFill>
+          <a:ln>
+            <a:noFill/>
+          </a:ln>
+          <a:effectLst/>
+        </p:spPr>
+        <p:style>
+          <a:lnRef idx="1">
+            <a:schemeClr val="accent1"/>
+          </a:lnRef>
+          <a:fillRef idx="3">
+            <a:schemeClr val="accent1"/>
+          </a:fillRef>
+          <a:effectRef idx="2">
+            <a:schemeClr val="accent1"/>
+          </a:effectRef>
+          <a:fontRef idx="minor">
+            <a:schemeClr val="lt1"/>
+          </a:fontRef>
+        </p:style>
+        <p:txBody>
+          <a:bodyPr rtlCol="0" anchor="ctr"/>
+          <a:lstStyle/>
+          <a:p>
+            <a:pPr algn="ctr"/>
+          </a:p>
+        </p:txBody>
+      </p:sp>
+      <p:sp>
+        <p:nvSpPr>
+          <p:cNvPr id="30" name="Oval 29"/>
+          <p:cNvSpPr/>
+          <p:nvPr/>
+        </p:nvSpPr>
+        <p:spPr>
+          <a:xfrm>
+            <a:off x="6263639" y="1581912"/>
+            <a:ext cx="246888" cy="246888"/>
+          </a:xfrm>
+          <a:prstGeom prst="ellipse">
+            <a:avLst/>
+          </a:prstGeom>
+          <a:solidFill>
+            <a:srgbClr val="FFFFFF"/>
+          </a:solidFill>
+          <a:ln>
+            <a:noFill/>
+          </a:ln>
+          <a:effectLst/>
+        </p:spPr>
+        <p:style>
+          <a:lnRef idx="1">
+            <a:schemeClr val="accent1"/>
+          </a:lnRef>
+          <a:fillRef idx="3">
+            <a:schemeClr val="accent1"/>
+          </a:fillRef>
+          <a:effectRef idx="2">
+            <a:schemeClr val="accent1"/>
+          </a:effectRef>
+          <a:fontRef idx="minor">
+            <a:schemeClr val="lt1"/>
+          </a:fontRef>
+        </p:style>
+        <p:txBody>
+          <a:bodyPr rtlCol="0" anchor="ctr"/>
+          <a:lstStyle/>
+          <a:p>
+            <a:pPr algn="ctr"/>
+          </a:p>
+        </p:txBody>
+      </p:sp>
+      <p:sp>
+        <p:nvSpPr>
+          <p:cNvPr id="31" name="TextBox 30"/>
+          <p:cNvSpPr txBox="1"/>
+          <p:nvPr/>
+        </p:nvSpPr>
+        <p:spPr>
+          <a:xfrm>
+            <a:off x="6263639" y="1581912"/>
+            <a:ext cx="246888" cy="246888"/>
+          </a:xfrm>
+          <a:prstGeom prst="rect">
+            <a:avLst/>
+          </a:prstGeom>
+          <a:noFill/>
+        </p:spPr>
+        <p:txBody>
+          <a:bodyPr wrap="square" lIns="45720" rIns="45720" tIns="18288" bIns="18288" anchor="t">
+            <a:spAutoFit/>
+          </a:bodyPr>
+          <a:lstStyle/>
+          <a:p>
+            <a:pPr algn="ctr">
+              <a:lnSpc>
+                <a:spcPct val="120000"/>
+              </a:lnSpc>
+            </a:pPr>
+            <a:r>
+              <a:rPr sz="1100" b="1">
+                <a:solidFill>
+                  <a:srgbClr val="2563EB"/>
+                </a:solidFill>
+                <a:latin typeface="Apple SD Gothic Neo"/>
+                <a:ea typeface="Apple SD Gothic Neo"/>
+                <a:cs typeface="Apple SD Gothic Neo"/>
+              </a:rPr>
+              <a:t>3</a:t>
+            </a:r>
+          </a:p>
+        </p:txBody>
+      </p:sp>
+      <p:sp>
+        <p:nvSpPr>
+          <p:cNvPr id="32" name="TextBox 31"/>
+          <p:cNvSpPr txBox="1"/>
+          <p:nvPr/>
+        </p:nvSpPr>
+        <p:spPr>
+          <a:xfrm>
+            <a:off x="6629399" y="1554480"/>
+            <a:ext cx="2103120" cy="292608"/>
+          </a:xfrm>
+          <a:prstGeom prst="rect">
+            <a:avLst/>
+          </a:prstGeom>
+          <a:noFill/>
+        </p:spPr>
+        <p:txBody>
+          <a:bodyPr wrap="square" lIns="45720" rIns="45720" tIns="18288" bIns="18288" anchor="t">
+            <a:spAutoFit/>
+          </a:bodyPr>
+          <a:lstStyle/>
+          <a:p>
+            <a:pPr algn="l">
+              <a:lnSpc>
+                <a:spcPct val="120000"/>
+              </a:lnSpc>
+            </a:pPr>
+            <a:r>
+              <a:rPr sz="1200" b="1">
+                <a:solidFill>
+                  <a:srgbClr val="FFFFFF"/>
+                </a:solidFill>
+                <a:latin typeface="Apple SD Gothic Neo"/>
+                <a:ea typeface="Apple SD Gothic Neo"/>
+                <a:cs typeface="Apple SD Gothic Neo"/>
+              </a:rPr>
+              <a:t>실험·문서화</a:t>
+            </a:r>
+          </a:p>
+        </p:txBody>
+      </p:sp>
+      <p:sp>
+        <p:nvSpPr>
+          <p:cNvPr id="33" name="TextBox 32"/>
+          <p:cNvSpPr txBox="1"/>
+          <p:nvPr/>
+        </p:nvSpPr>
+        <p:spPr>
+          <a:xfrm>
+            <a:off x="6309359" y="2057400"/>
+            <a:ext cx="2377440" cy="502920"/>
+          </a:xfrm>
+          <a:prstGeom prst="rect">
+            <a:avLst/>
+          </a:prstGeom>
+          <a:noFill/>
+        </p:spPr>
+        <p:txBody>
+          <a:bodyPr wrap="square" lIns="45720" rIns="45720" tIns="18288" bIns="18288" anchor="t">
+            <a:spAutoFit/>
+          </a:bodyPr>
+          <a:lstStyle/>
+          <a:p>
+            <a:pPr algn="l">
+              <a:lnSpc>
+                <a:spcPct val="120000"/>
+              </a:lnSpc>
+            </a:pPr>
+            <a:r>
+              <a:rPr sz="2200" b="1">
+                <a:solidFill>
+                  <a:srgbClr val="2563EB"/>
+                </a:solidFill>
+                <a:latin typeface="Apple SD Gothic Neo"/>
+                <a:ea typeface="Apple SD Gothic Neo"/>
+                <a:cs typeface="Apple SD Gothic Neo"/>
+              </a:rPr>
+              <a:t>조현빈</a:t>
+            </a:r>
+          </a:p>
+        </p:txBody>
+      </p:sp>
+      <p:sp>
+        <p:nvSpPr>
+          <p:cNvPr id="34" name="Rectangle 33"/>
+          <p:cNvSpPr/>
+          <p:nvPr/>
+        </p:nvSpPr>
+        <p:spPr>
+          <a:xfrm>
+            <a:off x="6309359" y="2651760"/>
+            <a:ext cx="1097280" cy="25400"/>
+          </a:xfrm>
+          <a:prstGeom prst="rect">
+            <a:avLst/>
+          </a:prstGeom>
+          <a:solidFill>
+            <a:srgbClr val="3B82F6"/>
+          </a:solidFill>
+          <a:ln>
+            <a:noFill/>
+          </a:ln>
+          <a:effectLst/>
+        </p:spPr>
+        <p:style>
+          <a:lnRef idx="1">
+            <a:schemeClr val="accent1"/>
+          </a:lnRef>
+          <a:fillRef idx="3">
+            <a:schemeClr val="accent1"/>
+          </a:fillRef>
+          <a:effectRef idx="2">
+            <a:schemeClr val="accent1"/>
+          </a:effectRef>
+          <a:fontRef idx="minor">
+            <a:schemeClr val="lt1"/>
+          </a:fontRef>
+        </p:style>
+        <p:txBody>
+          <a:bodyPr rtlCol="0" anchor="ctr"/>
+          <a:lstStyle/>
+          <a:p>
+            <a:pPr algn="ctr"/>
+          </a:p>
+        </p:txBody>
+      </p:sp>
+      <p:sp>
+        <p:nvSpPr>
+          <p:cNvPr id="35" name="TextBox 34"/>
+          <p:cNvSpPr txBox="1"/>
+          <p:nvPr/>
+        </p:nvSpPr>
+        <p:spPr>
+          <a:xfrm>
+            <a:off x="6309359" y="2788920"/>
+            <a:ext cx="2377440" cy="1417320"/>
+          </a:xfrm>
+          <a:prstGeom prst="rect">
+            <a:avLst/>
+          </a:prstGeom>
+          <a:noFill/>
+        </p:spPr>
+        <p:txBody>
+          <a:bodyPr wrap="square" lIns="45720" rIns="45720" tIns="18288" bIns="18288" anchor="t">
+            <a:spAutoFit/>
+          </a:bodyPr>
+          <a:lstStyle/>
+          <a:p>
+            <a:pPr algn="l">
+              <a:lnSpc>
+                <a:spcPct val="140000"/>
+              </a:lnSpc>
+            </a:pPr>
+            <a:r>
+              <a:rPr sz="1000" b="0">
+                <a:solidFill>
+                  <a:srgbClr val="0F172A"/>
+                </a:solidFill>
+                <a:latin typeface="Apple SD Gothic Neo"/>
+                <a:ea typeface="Apple SD Gothic Neo"/>
+                <a:cs typeface="Apple SD Gothic Neo"/>
+              </a:rPr>
+              <a:t>RQ1/RQ2 실험 · vector.c native 구현 · 보고서 작성</a:t>
+            </a:r>
+          </a:p>
+        </p:txBody>
+      </p:sp>
+      <p:sp>
+        <p:nvSpPr>
+          <p:cNvPr id="36" name="TextBox 35"/>
+          <p:cNvSpPr txBox="1"/>
+          <p:nvPr/>
+        </p:nvSpPr>
+        <p:spPr>
+          <a:xfrm>
+            <a:off x="6309359" y="4343400"/>
+            <a:ext cx="2377440" cy="274320"/>
+          </a:xfrm>
+          <a:prstGeom prst="rect">
+            <a:avLst/>
+          </a:prstGeom>
+          <a:noFill/>
+        </p:spPr>
+        <p:txBody>
+          <a:bodyPr wrap="square" lIns="45720" rIns="45720" tIns="18288" bIns="18288" anchor="t">
+            <a:spAutoFit/>
+          </a:bodyPr>
+          <a:lstStyle/>
+          <a:p>
+            <a:pPr algn="l">
+              <a:lnSpc>
+                <a:spcPct val="120000"/>
+              </a:lnSpc>
+            </a:pPr>
+            <a:r>
+              <a:rPr sz="800" b="1">
+                <a:solidFill>
+                  <a:srgbClr val="3B82F6"/>
+                </a:solidFill>
+                <a:latin typeface="Apple SD Gothic Neo"/>
+                <a:ea typeface="Apple SD Gothic Neo"/>
+                <a:cs typeface="Apple SD Gothic Neo"/>
+              </a:rPr>
+              <a:t>HIGHLIGHT</a:t>
+            </a:r>
+          </a:p>
+        </p:txBody>
+      </p:sp>
+      <p:sp>
+        <p:nvSpPr>
+          <p:cNvPr id="37" name="Rounded Rectangle 36"/>
+          <p:cNvSpPr/>
+          <p:nvPr/>
+        </p:nvSpPr>
+        <p:spPr>
+          <a:xfrm>
+            <a:off x="6309359" y="4617720"/>
+            <a:ext cx="2331720" cy="777240"/>
+          </a:xfrm>
+          <a:prstGeom prst="roundRect">
+            <a:avLst>
+              <a:gd name="adj" fmla="val 8000"/>
+            </a:avLst>
+          </a:prstGeom>
+          <a:solidFill>
+            <a:srgbClr val="FFFFFF"/>
+          </a:solidFill>
+          <a:ln w="9525">
+            <a:solidFill>
+              <a:srgbClr val="3B82F6"/>
+            </a:solidFill>
+          </a:ln>
+          <a:effectLst/>
+        </p:spPr>
+        <p:style>
+          <a:lnRef idx="1">
+            <a:schemeClr val="accent1"/>
+          </a:lnRef>
+          <a:fillRef idx="3">
+            <a:schemeClr val="accent1"/>
+          </a:fillRef>
+          <a:effectRef idx="2">
+            <a:schemeClr val="accent1"/>
+          </a:effectRef>
+          <a:fontRef idx="minor">
+            <a:schemeClr val="lt1"/>
+          </a:fontRef>
+        </p:style>
+        <p:txBody>
+          <a:bodyPr rtlCol="0" anchor="ctr"/>
+          <a:lstStyle/>
+          <a:p>
+            <a:pPr algn="ctr"/>
+          </a:p>
+        </p:txBody>
+      </p:sp>
+      <p:sp>
+        <p:nvSpPr>
+          <p:cNvPr id="38" name="TextBox 37"/>
+          <p:cNvSpPr txBox="1"/>
+          <p:nvPr/>
+        </p:nvSpPr>
+        <p:spPr>
+          <a:xfrm>
+            <a:off x="6400799" y="4663440"/>
+            <a:ext cx="2194560" cy="685800"/>
+          </a:xfrm>
+          <a:prstGeom prst="rect">
+            <a:avLst/>
+          </a:prstGeom>
+          <a:noFill/>
+        </p:spPr>
+        <p:txBody>
+          <a:bodyPr wrap="square" lIns="45720" rIns="45720" tIns="18288" bIns="18288" anchor="t">
+            <a:spAutoFit/>
+          </a:bodyPr>
+          <a:lstStyle/>
+          <a:p>
+            <a:pPr algn="l">
+              <a:lnSpc>
+                <a:spcPct val="135000"/>
+              </a:lnSpc>
+            </a:pPr>
+            <a:r>
+              <a:rPr sz="1000" b="1">
+                <a:solidFill>
+                  <a:srgbClr val="0F172A"/>
+                </a:solidFill>
+                <a:latin typeface="Apple SD Gothic Neo"/>
+                <a:ea typeface="Apple SD Gothic Neo"/>
+                <a:cs typeface="Apple SD Gothic Neo"/>
+              </a:rPr>
+              <a:t>vector.c +228 줄 native 구현</a:t>
+            </a:r>
+          </a:p>
+        </p:txBody>
+      </p:sp>
+      <p:sp>
+        <p:nvSpPr>
+          <p:cNvPr id="39" name="Rounded Rectangle 38"/>
+          <p:cNvSpPr/>
+          <p:nvPr/>
+        </p:nvSpPr>
+        <p:spPr>
+          <a:xfrm>
+            <a:off x="8915399" y="1463040"/>
+            <a:ext cx="2697480" cy="4023360"/>
+          </a:xfrm>
+          <a:prstGeom prst="roundRect">
+            <a:avLst>
+              <a:gd name="adj" fmla="val 8000"/>
+            </a:avLst>
+          </a:prstGeom>
+          <a:solidFill>
+            <a:srgbClr val="F8FAFC"/>
+          </a:solidFill>
+          <a:ln w="9525">
+            <a:solidFill>
+              <a:srgbClr val="E2E8F0"/>
+            </a:solidFill>
+          </a:ln>
+          <a:effectLst/>
+        </p:spPr>
+        <p:style>
+          <a:lnRef idx="1">
+            <a:schemeClr val="accent1"/>
+          </a:lnRef>
+          <a:fillRef idx="3">
+            <a:schemeClr val="accent1"/>
+          </a:fillRef>
+          <a:effectRef idx="2">
+            <a:schemeClr val="accent1"/>
+          </a:effectRef>
+          <a:fontRef idx="minor">
+            <a:schemeClr val="lt1"/>
+          </a:fontRef>
+        </p:style>
+        <p:txBody>
+          <a:bodyPr rtlCol="0" anchor="ctr"/>
+          <a:lstStyle/>
+          <a:p>
+            <a:pPr algn="ctr"/>
+          </a:p>
+        </p:txBody>
+      </p:sp>
+      <p:sp>
+        <p:nvSpPr>
+          <p:cNvPr id="40" name="Rectangle 39"/>
+          <p:cNvSpPr/>
+          <p:nvPr/>
+        </p:nvSpPr>
+        <p:spPr>
+          <a:xfrm>
+            <a:off x="8915399" y="1463040"/>
+            <a:ext cx="2697480" cy="457200"/>
+          </a:xfrm>
+          <a:prstGeom prst="rect">
+            <a:avLst/>
+          </a:prstGeom>
+          <a:solidFill>
+            <a:srgbClr val="2563EB"/>
+          </a:solidFill>
+          <a:ln>
+            <a:noFill/>
+          </a:ln>
+          <a:effectLst/>
+        </p:spPr>
+        <p:style>
+          <a:lnRef idx="1">
+            <a:schemeClr val="accent1"/>
+          </a:lnRef>
+          <a:fillRef idx="3">
+            <a:schemeClr val="accent1"/>
+          </a:fillRef>
+          <a:effectRef idx="2">
+            <a:schemeClr val="accent1"/>
+          </a:effectRef>
+          <a:fontRef idx="minor">
+            <a:schemeClr val="lt1"/>
+          </a:fontRef>
+        </p:style>
+        <p:txBody>
+          <a:bodyPr rtlCol="0" anchor="ctr"/>
+          <a:lstStyle/>
+          <a:p>
+            <a:pPr algn="ctr"/>
+          </a:p>
+        </p:txBody>
+      </p:sp>
+      <p:sp>
+        <p:nvSpPr>
+          <p:cNvPr id="41" name="Oval 40"/>
+          <p:cNvSpPr/>
+          <p:nvPr/>
+        </p:nvSpPr>
+        <p:spPr>
+          <a:xfrm>
+            <a:off x="9052559" y="1581912"/>
+            <a:ext cx="246888" cy="246888"/>
+          </a:xfrm>
+          <a:prstGeom prst="ellipse">
+            <a:avLst/>
+          </a:prstGeom>
+          <a:solidFill>
+            <a:srgbClr val="FFFFFF"/>
+          </a:solidFill>
+          <a:ln>
+            <a:noFill/>
+          </a:ln>
+          <a:effectLst/>
+        </p:spPr>
+        <p:style>
+          <a:lnRef idx="1">
+            <a:schemeClr val="accent1"/>
+          </a:lnRef>
+          <a:fillRef idx="3">
+            <a:schemeClr val="accent1"/>
+          </a:fillRef>
+          <a:effectRef idx="2">
+            <a:schemeClr val="accent1"/>
+          </a:effectRef>
+          <a:fontRef idx="minor">
+            <a:schemeClr val="lt1"/>
+          </a:fontRef>
+        </p:style>
+        <p:txBody>
+          <a:bodyPr rtlCol="0" anchor="ctr"/>
+          <a:lstStyle/>
+          <a:p>
+            <a:pPr algn="ctr"/>
+          </a:p>
+        </p:txBody>
+      </p:sp>
+      <p:sp>
+        <p:nvSpPr>
+          <p:cNvPr id="42" name="TextBox 41"/>
+          <p:cNvSpPr txBox="1"/>
+          <p:nvPr/>
+        </p:nvSpPr>
+        <p:spPr>
+          <a:xfrm>
+            <a:off x="9052559" y="1581912"/>
+            <a:ext cx="246888" cy="246888"/>
+          </a:xfrm>
+          <a:prstGeom prst="rect">
+            <a:avLst/>
+          </a:prstGeom>
+          <a:noFill/>
+        </p:spPr>
+        <p:txBody>
+          <a:bodyPr wrap="square" lIns="45720" rIns="45720" tIns="18288" bIns="18288" anchor="t">
+            <a:spAutoFit/>
+          </a:bodyPr>
+          <a:lstStyle/>
+          <a:p>
+            <a:pPr algn="ctr">
+              <a:lnSpc>
+                <a:spcPct val="120000"/>
+              </a:lnSpc>
+            </a:pPr>
+            <a:r>
+              <a:rPr sz="1100" b="1">
+                <a:solidFill>
+                  <a:srgbClr val="2563EB"/>
+                </a:solidFill>
+                <a:latin typeface="Apple SD Gothic Neo"/>
+                <a:ea typeface="Apple SD Gothic Neo"/>
+                <a:cs typeface="Apple SD Gothic Neo"/>
+              </a:rPr>
+              <a:t>4</a:t>
+            </a:r>
+          </a:p>
+        </p:txBody>
+      </p:sp>
+      <p:sp>
+        <p:nvSpPr>
+          <p:cNvPr id="43" name="TextBox 42"/>
+          <p:cNvSpPr txBox="1"/>
+          <p:nvPr/>
+        </p:nvSpPr>
+        <p:spPr>
+          <a:xfrm>
+            <a:off x="9418319" y="1554480"/>
+            <a:ext cx="2103120" cy="292608"/>
+          </a:xfrm>
+          <a:prstGeom prst="rect">
+            <a:avLst/>
+          </a:prstGeom>
+          <a:noFill/>
+        </p:spPr>
+        <p:txBody>
+          <a:bodyPr wrap="square" lIns="45720" rIns="45720" tIns="18288" bIns="18288" anchor="t">
+            <a:spAutoFit/>
+          </a:bodyPr>
+          <a:lstStyle/>
+          <a:p>
+            <a:pPr algn="l">
+              <a:lnSpc>
+                <a:spcPct val="120000"/>
+              </a:lnSpc>
+            </a:pPr>
+            <a:r>
+              <a:rPr sz="1200" b="1">
+                <a:solidFill>
+                  <a:srgbClr val="FFFFFF"/>
+                </a:solidFill>
+                <a:latin typeface="Apple SD Gothic Neo"/>
+                <a:ea typeface="Apple SD Gothic Neo"/>
+                <a:cs typeface="Apple SD Gothic Neo"/>
+              </a:rPr>
+              <a:t>분석·작도</a:t>
+            </a:r>
+          </a:p>
+        </p:txBody>
+      </p:sp>
+      <p:sp>
+        <p:nvSpPr>
+          <p:cNvPr id="44" name="TextBox 43"/>
+          <p:cNvSpPr txBox="1"/>
+          <p:nvPr/>
+        </p:nvSpPr>
+        <p:spPr>
+          <a:xfrm>
+            <a:off x="9098279" y="2057400"/>
+            <a:ext cx="2377440" cy="502920"/>
+          </a:xfrm>
+          <a:prstGeom prst="rect">
+            <a:avLst/>
+          </a:prstGeom>
+          <a:noFill/>
+        </p:spPr>
+        <p:txBody>
+          <a:bodyPr wrap="square" lIns="45720" rIns="45720" tIns="18288" bIns="18288" anchor="t">
+            <a:spAutoFit/>
+          </a:bodyPr>
+          <a:lstStyle/>
+          <a:p>
+            <a:pPr algn="l">
+              <a:lnSpc>
+                <a:spcPct val="120000"/>
+              </a:lnSpc>
+            </a:pPr>
+            <a:r>
+              <a:rPr sz="2200" b="1">
+                <a:solidFill>
+                  <a:srgbClr val="2563EB"/>
+                </a:solidFill>
+                <a:latin typeface="Apple SD Gothic Neo"/>
+                <a:ea typeface="Apple SD Gothic Neo"/>
+                <a:cs typeface="Apple SD Gothic Neo"/>
+              </a:rPr>
+              <a:t>이동욱</a:t>
+            </a:r>
+          </a:p>
+        </p:txBody>
+      </p:sp>
+      <p:sp>
+        <p:nvSpPr>
+          <p:cNvPr id="45" name="Rectangle 44"/>
+          <p:cNvSpPr/>
+          <p:nvPr/>
+        </p:nvSpPr>
+        <p:spPr>
+          <a:xfrm>
+            <a:off x="9098279" y="2651760"/>
+            <a:ext cx="1097280" cy="25400"/>
+          </a:xfrm>
+          <a:prstGeom prst="rect">
+            <a:avLst/>
+          </a:prstGeom>
+          <a:solidFill>
+            <a:srgbClr val="3B82F6"/>
+          </a:solidFill>
+          <a:ln>
+            <a:noFill/>
+          </a:ln>
+          <a:effectLst/>
+        </p:spPr>
+        <p:style>
+          <a:lnRef idx="1">
+            <a:schemeClr val="accent1"/>
+          </a:lnRef>
+          <a:fillRef idx="3">
+            <a:schemeClr val="accent1"/>
+          </a:fillRef>
+          <a:effectRef idx="2">
+            <a:schemeClr val="accent1"/>
+          </a:effectRef>
+          <a:fontRef idx="minor">
+            <a:schemeClr val="lt1"/>
+          </a:fontRef>
+        </p:style>
+        <p:txBody>
+          <a:bodyPr rtlCol="0" anchor="ctr"/>
+          <a:lstStyle/>
+          <a:p>
+            <a:pPr algn="ctr"/>
+          </a:p>
+        </p:txBody>
+      </p:sp>
+      <p:sp>
+        <p:nvSpPr>
+          <p:cNvPr id="46" name="TextBox 45"/>
+          <p:cNvSpPr txBox="1"/>
+          <p:nvPr/>
+        </p:nvSpPr>
+        <p:spPr>
+          <a:xfrm>
+            <a:off x="9098279" y="2788920"/>
+            <a:ext cx="2377440" cy="1417320"/>
+          </a:xfrm>
+          <a:prstGeom prst="rect">
+            <a:avLst/>
+          </a:prstGeom>
+          <a:noFill/>
+        </p:spPr>
+        <p:txBody>
+          <a:bodyPr wrap="square" lIns="45720" rIns="45720" tIns="18288" bIns="18288" anchor="t">
+            <a:spAutoFit/>
+          </a:bodyPr>
+          <a:lstStyle/>
+          <a:p>
+            <a:pPr algn="l">
+              <a:lnSpc>
+                <a:spcPct val="140000"/>
+              </a:lnSpc>
+            </a:pPr>
+            <a:r>
+              <a:rPr sz="1000" b="0">
+                <a:solidFill>
+                  <a:srgbClr val="0F172A"/>
+                </a:solidFill>
+                <a:latin typeface="Apple SD Gothic Neo"/>
+                <a:ea typeface="Apple SD Gothic Neo"/>
+                <a:cs typeface="Apple SD Gothic Neo"/>
+              </a:rPr>
+              <a:t>통계 분석 (CI·Two-Level) · 그림 작성 · RQ3 설계</a:t>
+            </a:r>
+          </a:p>
+        </p:txBody>
+      </p:sp>
+      <p:sp>
+        <p:nvSpPr>
+          <p:cNvPr id="47" name="TextBox 46"/>
+          <p:cNvSpPr txBox="1"/>
+          <p:nvPr/>
+        </p:nvSpPr>
+        <p:spPr>
+          <a:xfrm>
+            <a:off x="9098279" y="4343400"/>
+            <a:ext cx="2377440" cy="274320"/>
+          </a:xfrm>
+          <a:prstGeom prst="rect">
+            <a:avLst/>
+          </a:prstGeom>
+          <a:noFill/>
+        </p:spPr>
+        <p:txBody>
+          <a:bodyPr wrap="square" lIns="45720" rIns="45720" tIns="18288" bIns="18288" anchor="t">
+            <a:spAutoFit/>
+          </a:bodyPr>
+          <a:lstStyle/>
+          <a:p>
+            <a:pPr algn="l">
+              <a:lnSpc>
+                <a:spcPct val="120000"/>
+              </a:lnSpc>
+            </a:pPr>
+            <a:r>
+              <a:rPr sz="800" b="1">
+                <a:solidFill>
+                  <a:srgbClr val="3B82F6"/>
+                </a:solidFill>
+                <a:latin typeface="Apple SD Gothic Neo"/>
+                <a:ea typeface="Apple SD Gothic Neo"/>
+                <a:cs typeface="Apple SD Gothic Neo"/>
+              </a:rPr>
+              <a:t>HIGHLIGHT</a:t>
+            </a:r>
+          </a:p>
+        </p:txBody>
+      </p:sp>
+      <p:sp>
+        <p:nvSpPr>
+          <p:cNvPr id="48" name="Rounded Rectangle 47"/>
+          <p:cNvSpPr/>
+          <p:nvPr/>
+        </p:nvSpPr>
+        <p:spPr>
+          <a:xfrm>
+            <a:off x="9098279" y="4617720"/>
+            <a:ext cx="2331720" cy="777240"/>
+          </a:xfrm>
+          <a:prstGeom prst="roundRect">
+            <a:avLst>
+              <a:gd name="adj" fmla="val 8000"/>
+            </a:avLst>
+          </a:prstGeom>
+          <a:solidFill>
+            <a:srgbClr val="FFFFFF"/>
+          </a:solidFill>
+          <a:ln w="9525">
+            <a:solidFill>
+              <a:srgbClr val="3B82F6"/>
+            </a:solidFill>
+          </a:ln>
+          <a:effectLst/>
+        </p:spPr>
+        <p:style>
+          <a:lnRef idx="1">
+            <a:schemeClr val="accent1"/>
+          </a:lnRef>
+          <a:fillRef idx="3">
+            <a:schemeClr val="accent1"/>
+          </a:fillRef>
+          <a:effectRef idx="2">
+            <a:schemeClr val="accent1"/>
+          </a:effectRef>
+          <a:fontRef idx="minor">
+            <a:schemeClr val="lt1"/>
+          </a:fontRef>
+        </p:style>
+        <p:txBody>
+          <a:bodyPr rtlCol="0" anchor="ctr"/>
+          <a:lstStyle/>
+          <a:p>
+            <a:pPr algn="ctr"/>
+          </a:p>
+        </p:txBody>
+      </p:sp>
+      <p:sp>
+        <p:nvSpPr>
+          <p:cNvPr id="49" name="TextBox 48"/>
+          <p:cNvSpPr txBox="1"/>
+          <p:nvPr/>
+        </p:nvSpPr>
+        <p:spPr>
+          <a:xfrm>
+            <a:off x="9189719" y="4663440"/>
+            <a:ext cx="2194560" cy="685800"/>
+          </a:xfrm>
+          <a:prstGeom prst="rect">
+            <a:avLst/>
+          </a:prstGeom>
+          <a:noFill/>
+        </p:spPr>
+        <p:txBody>
+          <a:bodyPr wrap="square" lIns="45720" rIns="45720" tIns="18288" bIns="18288" anchor="t">
+            <a:spAutoFit/>
+          </a:bodyPr>
+          <a:lstStyle/>
+          <a:p>
+            <a:pPr algn="l">
+              <a:lnSpc>
+                <a:spcPct val="135000"/>
+              </a:lnSpc>
+            </a:pPr>
+            <a:r>
+              <a:rPr sz="1000" b="1">
+                <a:solidFill>
+                  <a:srgbClr val="0F172A"/>
+                </a:solidFill>
+                <a:latin typeface="Apple SD Gothic Neo"/>
+                <a:ea typeface="Apple SD Gothic Neo"/>
+                <a:cs typeface="Apple SD Gothic Neo"/>
+              </a:rPr>
+              <a:t>Two-Level +19.6%p 분해 · 그림 8 종</a:t>
+            </a:r>
+          </a:p>
+        </p:txBody>
+      </p:sp>
+      <p:sp>
+        <p:nvSpPr>
+          <p:cNvPr id="50" name="Rounded Rectangle 49"/>
+          <p:cNvSpPr/>
+          <p:nvPr/>
+        </p:nvSpPr>
+        <p:spPr>
+          <a:xfrm>
+            <a:off x="548640" y="5623560"/>
             <a:ext cx="11064240" cy="502920"/>
           </a:xfrm>
           <a:prstGeom prst="roundRect">
@@ -11977,13 +13492,13 @@
       </p:sp>
       <p:sp>
         <p:nvSpPr>
-          <p:cNvPr id="8" name="TextBox 7"/>
-          <p:cNvSpPr txBox="1"/>
-          <p:nvPr/>
-        </p:nvSpPr>
-        <p:spPr>
-          <a:xfrm>
-            <a:off x="777240" y="5532120"/>
+          <p:cNvPr id="51" name="TextBox 50"/>
+          <p:cNvSpPr txBox="1"/>
+          <p:nvPr/>
+        </p:nvSpPr>
+        <p:spPr>
+          <a:xfrm>
+            <a:off x="777240" y="5669280"/>
             <a:ext cx="10515600" cy="411480"/>
           </a:xfrm>
           <a:prstGeom prst="rect">
@@ -12003,7 +13518,7 @@
               </a:lnSpc>
             </a:pPr>
             <a:r>
-              <a:rPr sz="1100" b="1">
+              <a:rPr sz="1000" b="1">
                 <a:solidFill>
                   <a:srgbClr val="3B82F6"/>
                 </a:solidFill>
@@ -12025,6 +13540,1710 @@
 </file>
 
 <file path=ppt/slides/slide16.xml><?xml version="1.0" encoding="utf-8"?>
+<p:sld xmlns:a="http://schemas.openxmlformats.org/drawingml/2006/main" xmlns:p="http://schemas.openxmlformats.org/presentationml/2006/main" xmlns:r="http://schemas.openxmlformats.org/officeDocument/2006/relationships">
+  <p:cSld>
+    <p:bg>
+      <p:bgPr>
+        <a:solidFill>
+          <a:srgbClr val="FFFFFF"/>
+        </a:solidFill>
+        <a:effectLst/>
+      </p:bgPr>
+    </p:bg>
+    <p:spTree>
+      <p:nvGrpSpPr>
+        <p:cNvPr id="1" name=""/>
+        <p:cNvGrpSpPr/>
+        <p:nvPr/>
+      </p:nvGrpSpPr>
+      <p:grpSpPr/>
+      <p:sp>
+        <p:nvSpPr>
+          <p:cNvPr id="2" name="Rectangle 1"/>
+          <p:cNvSpPr/>
+          <p:nvPr/>
+        </p:nvSpPr>
+        <p:spPr>
+          <a:xfrm>
+            <a:off x="731520" y="502920"/>
+            <a:ext cx="54864" cy="777240"/>
+          </a:xfrm>
+          <a:prstGeom prst="rect">
+            <a:avLst/>
+          </a:prstGeom>
+          <a:solidFill>
+            <a:srgbClr val="2563EB"/>
+          </a:solidFill>
+          <a:ln>
+            <a:noFill/>
+          </a:ln>
+          <a:effectLst/>
+        </p:spPr>
+        <p:style>
+          <a:lnRef idx="1">
+            <a:schemeClr val="accent1"/>
+          </a:lnRef>
+          <a:fillRef idx="3">
+            <a:schemeClr val="accent1"/>
+          </a:fillRef>
+          <a:effectRef idx="2">
+            <a:schemeClr val="accent1"/>
+          </a:effectRef>
+          <a:fontRef idx="minor">
+            <a:schemeClr val="lt1"/>
+          </a:fontRef>
+        </p:style>
+        <p:txBody>
+          <a:bodyPr rtlCol="0" anchor="ctr"/>
+          <a:lstStyle/>
+          <a:p>
+            <a:pPr algn="ctr"/>
+          </a:p>
+        </p:txBody>
+      </p:sp>
+      <p:sp>
+        <p:nvSpPr>
+          <p:cNvPr id="3" name="TextBox 2"/>
+          <p:cNvSpPr txBox="1"/>
+          <p:nvPr/>
+        </p:nvSpPr>
+        <p:spPr>
+          <a:xfrm>
+            <a:off x="914400" y="411480"/>
+            <a:ext cx="10515600" cy="548640"/>
+          </a:xfrm>
+          <a:prstGeom prst="rect">
+            <a:avLst/>
+          </a:prstGeom>
+          <a:noFill/>
+        </p:spPr>
+        <p:txBody>
+          <a:bodyPr wrap="square" lIns="45720" rIns="45720" tIns="18288" bIns="18288" anchor="t">
+            <a:spAutoFit/>
+          </a:bodyPr>
+          <a:lstStyle/>
+          <a:p>
+            <a:pPr algn="l">
+              <a:lnSpc>
+                <a:spcPct val="120000"/>
+              </a:lnSpc>
+            </a:pPr>
+            <a:r>
+              <a:rPr sz="2400" b="1">
+                <a:solidFill>
+                  <a:srgbClr val="0F172A"/>
+                </a:solidFill>
+                <a:latin typeface="Apple SD Gothic Neo"/>
+                <a:ea typeface="Apple SD Gothic Neo"/>
+                <a:cs typeface="Apple SD Gothic Neo"/>
+              </a:rPr>
+              <a:t>결론 — 본 발표의 4 핵심 발견</a:t>
+            </a:r>
+          </a:p>
+        </p:txBody>
+      </p:sp>
+      <p:sp>
+        <p:nvSpPr>
+          <p:cNvPr id="4" name="TextBox 3"/>
+          <p:cNvSpPr txBox="1"/>
+          <p:nvPr/>
+        </p:nvSpPr>
+        <p:spPr>
+          <a:xfrm>
+            <a:off x="914400" y="960120"/>
+            <a:ext cx="10972800" cy="320040"/>
+          </a:xfrm>
+          <a:prstGeom prst="rect">
+            <a:avLst/>
+          </a:prstGeom>
+          <a:noFill/>
+        </p:spPr>
+        <p:txBody>
+          <a:bodyPr wrap="square" lIns="45720" rIns="45720" tIns="18288" bIns="18288" anchor="t">
+            <a:spAutoFit/>
+          </a:bodyPr>
+          <a:lstStyle/>
+          <a:p>
+            <a:pPr algn="l">
+              <a:lnSpc>
+                <a:spcPct val="120000"/>
+              </a:lnSpc>
+            </a:pPr>
+            <a:r>
+              <a:rPr sz="1100" b="0">
+                <a:solidFill>
+                  <a:srgbClr val="64748B"/>
+                </a:solidFill>
+                <a:latin typeface="Apple SD Gothic Neo"/>
+                <a:ea typeface="Apple SD Gothic Neo"/>
+                <a:cs typeface="Apple SD Gothic Neo"/>
+              </a:rPr>
+              <a:t>RQ1 negative · RQ2 외적 타당성 · Two-Level 분해 · RQ3 설계</a:t>
+            </a:r>
+          </a:p>
+        </p:txBody>
+      </p:sp>
+      <p:sp>
+        <p:nvSpPr>
+          <p:cNvPr id="5" name="Rectangle 4"/>
+          <p:cNvSpPr/>
+          <p:nvPr/>
+        </p:nvSpPr>
+        <p:spPr>
+          <a:xfrm>
+            <a:off x="548640" y="1325880"/>
+            <a:ext cx="11064240" cy="12700"/>
+          </a:xfrm>
+          <a:prstGeom prst="rect">
+            <a:avLst/>
+          </a:prstGeom>
+          <a:solidFill>
+            <a:srgbClr val="E2E8F0"/>
+          </a:solidFill>
+          <a:ln>
+            <a:noFill/>
+          </a:ln>
+          <a:effectLst/>
+        </p:spPr>
+        <p:style>
+          <a:lnRef idx="1">
+            <a:schemeClr val="accent1"/>
+          </a:lnRef>
+          <a:fillRef idx="3">
+            <a:schemeClr val="accent1"/>
+          </a:fillRef>
+          <a:effectRef idx="2">
+            <a:schemeClr val="accent1"/>
+          </a:effectRef>
+          <a:fontRef idx="minor">
+            <a:schemeClr val="lt1"/>
+          </a:fontRef>
+        </p:style>
+        <p:txBody>
+          <a:bodyPr rtlCol="0" anchor="ctr"/>
+          <a:lstStyle/>
+          <a:p>
+            <a:pPr algn="ctr"/>
+          </a:p>
+        </p:txBody>
+      </p:sp>
+      <p:sp>
+        <p:nvSpPr>
+          <p:cNvPr id="6" name="TextBox 5"/>
+          <p:cNvSpPr txBox="1"/>
+          <p:nvPr/>
+        </p:nvSpPr>
+        <p:spPr>
+          <a:xfrm>
+            <a:off x="11247120" y="6446520"/>
+            <a:ext cx="914400" cy="320040"/>
+          </a:xfrm>
+          <a:prstGeom prst="rect">
+            <a:avLst/>
+          </a:prstGeom>
+          <a:noFill/>
+        </p:spPr>
+        <p:txBody>
+          <a:bodyPr wrap="square" lIns="45720" rIns="45720" tIns="18288" bIns="18288" anchor="t">
+            <a:spAutoFit/>
+          </a:bodyPr>
+          <a:lstStyle/>
+          <a:p>
+            <a:pPr algn="r">
+              <a:lnSpc>
+                <a:spcPct val="120000"/>
+              </a:lnSpc>
+            </a:pPr>
+            <a:r>
+              <a:rPr sz="900" b="0">
+                <a:solidFill>
+                  <a:srgbClr val="64748B"/>
+                </a:solidFill>
+                <a:latin typeface="Apple SD Gothic Neo"/>
+                <a:ea typeface="Apple SD Gothic Neo"/>
+                <a:cs typeface="Apple SD Gothic Neo"/>
+              </a:rPr>
+              <a:t>16 / 17</a:t>
+            </a:r>
+          </a:p>
+        </p:txBody>
+      </p:sp>
+      <p:sp>
+        <p:nvSpPr>
+          <p:cNvPr id="7" name="Rounded Rectangle 6"/>
+          <p:cNvSpPr/>
+          <p:nvPr/>
+        </p:nvSpPr>
+        <p:spPr>
+          <a:xfrm>
+            <a:off x="548640" y="1417320"/>
+            <a:ext cx="2697480" cy="4114800"/>
+          </a:xfrm>
+          <a:prstGeom prst="roundRect">
+            <a:avLst>
+              <a:gd name="adj" fmla="val 8000"/>
+            </a:avLst>
+          </a:prstGeom>
+          <a:solidFill>
+            <a:srgbClr val="F8FAFC"/>
+          </a:solidFill>
+          <a:ln w="9525">
+            <a:solidFill>
+              <a:srgbClr val="E2E8F0"/>
+            </a:solidFill>
+          </a:ln>
+          <a:effectLst/>
+        </p:spPr>
+        <p:style>
+          <a:lnRef idx="1">
+            <a:schemeClr val="accent1"/>
+          </a:lnRef>
+          <a:fillRef idx="3">
+            <a:schemeClr val="accent1"/>
+          </a:fillRef>
+          <a:effectRef idx="2">
+            <a:schemeClr val="accent1"/>
+          </a:effectRef>
+          <a:fontRef idx="minor">
+            <a:schemeClr val="lt1"/>
+          </a:fontRef>
+        </p:style>
+        <p:txBody>
+          <a:bodyPr rtlCol="0" anchor="ctr"/>
+          <a:lstStyle/>
+          <a:p>
+            <a:pPr algn="ctr"/>
+          </a:p>
+        </p:txBody>
+      </p:sp>
+      <p:sp>
+        <p:nvSpPr>
+          <p:cNvPr id="8" name="Rectangle 7"/>
+          <p:cNvSpPr/>
+          <p:nvPr/>
+        </p:nvSpPr>
+        <p:spPr>
+          <a:xfrm>
+            <a:off x="548640" y="1417320"/>
+            <a:ext cx="2697480" cy="502920"/>
+          </a:xfrm>
+          <a:prstGeom prst="rect">
+            <a:avLst/>
+          </a:prstGeom>
+          <a:solidFill>
+            <a:srgbClr val="2563EB"/>
+          </a:solidFill>
+          <a:ln>
+            <a:noFill/>
+          </a:ln>
+          <a:effectLst/>
+        </p:spPr>
+        <p:style>
+          <a:lnRef idx="1">
+            <a:schemeClr val="accent1"/>
+          </a:lnRef>
+          <a:fillRef idx="3">
+            <a:schemeClr val="accent1"/>
+          </a:fillRef>
+          <a:effectRef idx="2">
+            <a:schemeClr val="accent1"/>
+          </a:effectRef>
+          <a:fontRef idx="minor">
+            <a:schemeClr val="lt1"/>
+          </a:fontRef>
+        </p:style>
+        <p:txBody>
+          <a:bodyPr rtlCol="0" anchor="ctr"/>
+          <a:lstStyle/>
+          <a:p>
+            <a:pPr algn="ctr"/>
+          </a:p>
+        </p:txBody>
+      </p:sp>
+      <p:sp>
+        <p:nvSpPr>
+          <p:cNvPr id="9" name="TextBox 8"/>
+          <p:cNvSpPr txBox="1"/>
+          <p:nvPr/>
+        </p:nvSpPr>
+        <p:spPr>
+          <a:xfrm>
+            <a:off x="731520" y="1508760"/>
+            <a:ext cx="2377440" cy="365760"/>
+          </a:xfrm>
+          <a:prstGeom prst="rect">
+            <a:avLst/>
+          </a:prstGeom>
+          <a:noFill/>
+        </p:spPr>
+        <p:txBody>
+          <a:bodyPr wrap="square" lIns="45720" rIns="45720" tIns="18288" bIns="18288" anchor="t">
+            <a:spAutoFit/>
+          </a:bodyPr>
+          <a:lstStyle/>
+          <a:p>
+            <a:pPr algn="l">
+              <a:lnSpc>
+                <a:spcPct val="120000"/>
+              </a:lnSpc>
+            </a:pPr>
+            <a:r>
+              <a:rPr sz="1400" b="1">
+                <a:solidFill>
+                  <a:srgbClr val="FFFFFF"/>
+                </a:solidFill>
+                <a:latin typeface="Apple SD Gothic Neo"/>
+                <a:ea typeface="Apple SD Gothic Neo"/>
+                <a:cs typeface="Apple SD Gothic Neo"/>
+              </a:rPr>
+              <a:t>RQ1</a:t>
+            </a:r>
+          </a:p>
+        </p:txBody>
+      </p:sp>
+      <p:sp>
+        <p:nvSpPr>
+          <p:cNvPr id="10" name="TextBox 9"/>
+          <p:cNvSpPr txBox="1"/>
+          <p:nvPr/>
+        </p:nvSpPr>
+        <p:spPr>
+          <a:xfrm>
+            <a:off x="731520" y="2057400"/>
+            <a:ext cx="2377440" cy="777240"/>
+          </a:xfrm>
+          <a:prstGeom prst="rect">
+            <a:avLst/>
+          </a:prstGeom>
+          <a:noFill/>
+        </p:spPr>
+        <p:txBody>
+          <a:bodyPr wrap="square" lIns="45720" rIns="45720" tIns="18288" bIns="18288" anchor="t">
+            <a:spAutoFit/>
+          </a:bodyPr>
+          <a:lstStyle/>
+          <a:p>
+            <a:pPr algn="l">
+              <a:lnSpc>
+                <a:spcPct val="130000"/>
+              </a:lnSpc>
+            </a:pPr>
+            <a:r>
+              <a:rPr sz="1200" b="1">
+                <a:solidFill>
+                  <a:srgbClr val="0F172A"/>
+                </a:solidFill>
+                <a:latin typeface="Apple SD Gothic Neo"/>
+                <a:ea typeface="Apple SD Gothic Neo"/>
+                <a:cs typeface="Apple SD Gothic Neo"/>
+              </a:rPr>
+              <a:t>Skew 지표는 Q-error 를 예측하지 못한다</a:t>
+            </a:r>
+          </a:p>
+        </p:txBody>
+      </p:sp>
+      <p:sp>
+        <p:nvSpPr>
+          <p:cNvPr id="11" name="Rounded Rectangle 10"/>
+          <p:cNvSpPr/>
+          <p:nvPr/>
+        </p:nvSpPr>
+        <p:spPr>
+          <a:xfrm>
+            <a:off x="731520" y="2926080"/>
+            <a:ext cx="2331720" cy="960120"/>
+          </a:xfrm>
+          <a:prstGeom prst="roundRect">
+            <a:avLst>
+              <a:gd name="adj" fmla="val 8000"/>
+            </a:avLst>
+          </a:prstGeom>
+          <a:solidFill>
+            <a:srgbClr val="FFFFFF"/>
+          </a:solidFill>
+          <a:ln w="19050">
+            <a:solidFill>
+              <a:srgbClr val="3B82F6"/>
+            </a:solidFill>
+          </a:ln>
+          <a:effectLst/>
+        </p:spPr>
+        <p:style>
+          <a:lnRef idx="1">
+            <a:schemeClr val="accent1"/>
+          </a:lnRef>
+          <a:fillRef idx="3">
+            <a:schemeClr val="accent1"/>
+          </a:fillRef>
+          <a:effectRef idx="2">
+            <a:schemeClr val="accent1"/>
+          </a:effectRef>
+          <a:fontRef idx="minor">
+            <a:schemeClr val="lt1"/>
+          </a:fontRef>
+        </p:style>
+        <p:txBody>
+          <a:bodyPr rtlCol="0" anchor="ctr"/>
+          <a:lstStyle/>
+          <a:p>
+            <a:pPr algn="ctr"/>
+          </a:p>
+        </p:txBody>
+      </p:sp>
+      <p:sp>
+        <p:nvSpPr>
+          <p:cNvPr id="12" name="TextBox 11"/>
+          <p:cNvSpPr txBox="1"/>
+          <p:nvPr/>
+        </p:nvSpPr>
+        <p:spPr>
+          <a:xfrm>
+            <a:off x="731520" y="2971800"/>
+            <a:ext cx="2331720" cy="502920"/>
+          </a:xfrm>
+          <a:prstGeom prst="rect">
+            <a:avLst/>
+          </a:prstGeom>
+          <a:noFill/>
+        </p:spPr>
+        <p:txBody>
+          <a:bodyPr wrap="square" lIns="45720" rIns="45720" tIns="18288" bIns="18288" anchor="t">
+            <a:spAutoFit/>
+          </a:bodyPr>
+          <a:lstStyle/>
+          <a:p>
+            <a:pPr algn="ctr">
+              <a:lnSpc>
+                <a:spcPct val="120000"/>
+              </a:lnSpc>
+            </a:pPr>
+            <a:r>
+              <a:rPr sz="2200" b="1">
+                <a:solidFill>
+                  <a:srgbClr val="2563EB"/>
+                </a:solidFill>
+                <a:latin typeface="Apple SD Gothic Neo"/>
+                <a:ea typeface="Apple SD Gothic Neo"/>
+                <a:cs typeface="Apple SD Gothic Neo"/>
+              </a:rPr>
+              <a:t>48 / 48</a:t>
+            </a:r>
+          </a:p>
+        </p:txBody>
+      </p:sp>
+      <p:sp>
+        <p:nvSpPr>
+          <p:cNvPr id="13" name="TextBox 12"/>
+          <p:cNvSpPr txBox="1"/>
+          <p:nvPr/>
+        </p:nvSpPr>
+        <p:spPr>
+          <a:xfrm>
+            <a:off x="731520" y="3474720"/>
+            <a:ext cx="2331720" cy="365760"/>
+          </a:xfrm>
+          <a:prstGeom prst="rect">
+            <a:avLst/>
+          </a:prstGeom>
+          <a:noFill/>
+        </p:spPr>
+        <p:txBody>
+          <a:bodyPr wrap="square" lIns="45720" rIns="45720" tIns="18288" bIns="18288" anchor="t">
+            <a:spAutoFit/>
+          </a:bodyPr>
+          <a:lstStyle/>
+          <a:p>
+            <a:pPr algn="ctr">
+              <a:lnSpc>
+                <a:spcPct val="130000"/>
+              </a:lnSpc>
+            </a:pPr>
+            <a:r>
+              <a:rPr sz="800" b="0">
+                <a:solidFill>
+                  <a:srgbClr val="64748B"/>
+                </a:solidFill>
+                <a:latin typeface="Apple SD Gothic Neo"/>
+                <a:ea typeface="Apple SD Gothic Neo"/>
+                <a:cs typeface="Apple SD Gothic Neo"/>
+              </a:rPr>
+              <a:t>조합 모두 |ρ| &lt; 0.2</a:t>
+            </a:r>
+          </a:p>
+        </p:txBody>
+      </p:sp>
+      <p:sp>
+        <p:nvSpPr>
+          <p:cNvPr id="14" name="TextBox 13"/>
+          <p:cNvSpPr txBox="1"/>
+          <p:nvPr/>
+        </p:nvSpPr>
+        <p:spPr>
+          <a:xfrm>
+            <a:off x="731520" y="4023360"/>
+            <a:ext cx="2377440" cy="1417320"/>
+          </a:xfrm>
+          <a:prstGeom prst="rect">
+            <a:avLst/>
+          </a:prstGeom>
+          <a:noFill/>
+        </p:spPr>
+        <p:txBody>
+          <a:bodyPr wrap="square" lIns="45720" rIns="45720" tIns="18288" bIns="18288" anchor="t">
+            <a:spAutoFit/>
+          </a:bodyPr>
+          <a:lstStyle/>
+          <a:p>
+            <a:pPr algn="l">
+              <a:lnSpc>
+                <a:spcPct val="140000"/>
+              </a:lnSpc>
+            </a:pPr>
+            <a:r>
+              <a:rPr sz="900" b="0">
+                <a:solidFill>
+                  <a:srgbClr val="0F172A"/>
+                </a:solidFill>
+                <a:latin typeface="Apple SD Gothic Neo"/>
+                <a:ea typeface="Apple SD Gothic Neo"/>
+                <a:cs typeface="Apple SD Gothic Neo"/>
+              </a:rPr>
+              <a:t>글로벌 4 + 로컬 4 = 48 조합 모두 negative — query-side feature 사전 layer 정의 불가능성을 정량 증명 (Cohen 1988)</a:t>
+            </a:r>
+          </a:p>
+        </p:txBody>
+      </p:sp>
+      <p:sp>
+        <p:nvSpPr>
+          <p:cNvPr id="15" name="Rounded Rectangle 14"/>
+          <p:cNvSpPr/>
+          <p:nvPr/>
+        </p:nvSpPr>
+        <p:spPr>
+          <a:xfrm>
+            <a:off x="3337560" y="1417320"/>
+            <a:ext cx="2697480" cy="4114800"/>
+          </a:xfrm>
+          <a:prstGeom prst="roundRect">
+            <a:avLst>
+              <a:gd name="adj" fmla="val 8000"/>
+            </a:avLst>
+          </a:prstGeom>
+          <a:solidFill>
+            <a:srgbClr val="F8FAFC"/>
+          </a:solidFill>
+          <a:ln w="9525">
+            <a:solidFill>
+              <a:srgbClr val="E2E8F0"/>
+            </a:solidFill>
+          </a:ln>
+          <a:effectLst/>
+        </p:spPr>
+        <p:style>
+          <a:lnRef idx="1">
+            <a:schemeClr val="accent1"/>
+          </a:lnRef>
+          <a:fillRef idx="3">
+            <a:schemeClr val="accent1"/>
+          </a:fillRef>
+          <a:effectRef idx="2">
+            <a:schemeClr val="accent1"/>
+          </a:effectRef>
+          <a:fontRef idx="minor">
+            <a:schemeClr val="lt1"/>
+          </a:fontRef>
+        </p:style>
+        <p:txBody>
+          <a:bodyPr rtlCol="0" anchor="ctr"/>
+          <a:lstStyle/>
+          <a:p>
+            <a:pPr algn="ctr"/>
+          </a:p>
+        </p:txBody>
+      </p:sp>
+      <p:sp>
+        <p:nvSpPr>
+          <p:cNvPr id="16" name="Rectangle 15"/>
+          <p:cNvSpPr/>
+          <p:nvPr/>
+        </p:nvSpPr>
+        <p:spPr>
+          <a:xfrm>
+            <a:off x="3337560" y="1417320"/>
+            <a:ext cx="2697480" cy="502920"/>
+          </a:xfrm>
+          <a:prstGeom prst="rect">
+            <a:avLst/>
+          </a:prstGeom>
+          <a:solidFill>
+            <a:srgbClr val="2563EB"/>
+          </a:solidFill>
+          <a:ln>
+            <a:noFill/>
+          </a:ln>
+          <a:effectLst/>
+        </p:spPr>
+        <p:style>
+          <a:lnRef idx="1">
+            <a:schemeClr val="accent1"/>
+          </a:lnRef>
+          <a:fillRef idx="3">
+            <a:schemeClr val="accent1"/>
+          </a:fillRef>
+          <a:effectRef idx="2">
+            <a:schemeClr val="accent1"/>
+          </a:effectRef>
+          <a:fontRef idx="minor">
+            <a:schemeClr val="lt1"/>
+          </a:fontRef>
+        </p:style>
+        <p:txBody>
+          <a:bodyPr rtlCol="0" anchor="ctr"/>
+          <a:lstStyle/>
+          <a:p>
+            <a:pPr algn="ctr"/>
+          </a:p>
+        </p:txBody>
+      </p:sp>
+      <p:sp>
+        <p:nvSpPr>
+          <p:cNvPr id="17" name="TextBox 16"/>
+          <p:cNvSpPr txBox="1"/>
+          <p:nvPr/>
+        </p:nvSpPr>
+        <p:spPr>
+          <a:xfrm>
+            <a:off x="3520440" y="1508760"/>
+            <a:ext cx="2377440" cy="365760"/>
+          </a:xfrm>
+          <a:prstGeom prst="rect">
+            <a:avLst/>
+          </a:prstGeom>
+          <a:noFill/>
+        </p:spPr>
+        <p:txBody>
+          <a:bodyPr wrap="square" lIns="45720" rIns="45720" tIns="18288" bIns="18288" anchor="t">
+            <a:spAutoFit/>
+          </a:bodyPr>
+          <a:lstStyle/>
+          <a:p>
+            <a:pPr algn="l">
+              <a:lnSpc>
+                <a:spcPct val="120000"/>
+              </a:lnSpc>
+            </a:pPr>
+            <a:r>
+              <a:rPr sz="1400" b="1">
+                <a:solidFill>
+                  <a:srgbClr val="FFFFFF"/>
+                </a:solidFill>
+                <a:latin typeface="Apple SD Gothic Neo"/>
+                <a:ea typeface="Apple SD Gothic Neo"/>
+                <a:cs typeface="Apple SD Gothic Neo"/>
+              </a:rPr>
+              <a:t>RQ2</a:t>
+            </a:r>
+          </a:p>
+        </p:txBody>
+      </p:sp>
+      <p:sp>
+        <p:nvSpPr>
+          <p:cNvPr id="18" name="TextBox 17"/>
+          <p:cNvSpPr txBox="1"/>
+          <p:nvPr/>
+        </p:nvSpPr>
+        <p:spPr>
+          <a:xfrm>
+            <a:off x="3520440" y="2057400"/>
+            <a:ext cx="2377440" cy="777240"/>
+          </a:xfrm>
+          <a:prstGeom prst="rect">
+            <a:avLst/>
+          </a:prstGeom>
+          <a:noFill/>
+        </p:spPr>
+        <p:txBody>
+          <a:bodyPr wrap="square" lIns="45720" rIns="45720" tIns="18288" bIns="18288" anchor="t">
+            <a:spAutoFit/>
+          </a:bodyPr>
+          <a:lstStyle/>
+          <a:p>
+            <a:pPr algn="l">
+              <a:lnSpc>
+                <a:spcPct val="130000"/>
+              </a:lnSpc>
+            </a:pPr>
+            <a:r>
+              <a:rPr sz="1200" b="1">
+                <a:solidFill>
+                  <a:srgbClr val="0F172A"/>
+                </a:solidFill>
+                <a:latin typeface="Apple SD Gothic Neo"/>
+                <a:ea typeface="Apple SD Gothic Neo"/>
+                <a:cs typeface="Apple SD Gothic Neo"/>
+              </a:rPr>
+              <a:t>Skew-Aware Sampling 의 외적 타당성</a:t>
+            </a:r>
+          </a:p>
+        </p:txBody>
+      </p:sp>
+      <p:sp>
+        <p:nvSpPr>
+          <p:cNvPr id="19" name="Rounded Rectangle 18"/>
+          <p:cNvSpPr/>
+          <p:nvPr/>
+        </p:nvSpPr>
+        <p:spPr>
+          <a:xfrm>
+            <a:off x="3520440" y="2926080"/>
+            <a:ext cx="2331720" cy="960120"/>
+          </a:xfrm>
+          <a:prstGeom prst="roundRect">
+            <a:avLst>
+              <a:gd name="adj" fmla="val 8000"/>
+            </a:avLst>
+          </a:prstGeom>
+          <a:solidFill>
+            <a:srgbClr val="FFFFFF"/>
+          </a:solidFill>
+          <a:ln w="19050">
+            <a:solidFill>
+              <a:srgbClr val="3B82F6"/>
+            </a:solidFill>
+          </a:ln>
+          <a:effectLst/>
+        </p:spPr>
+        <p:style>
+          <a:lnRef idx="1">
+            <a:schemeClr val="accent1"/>
+          </a:lnRef>
+          <a:fillRef idx="3">
+            <a:schemeClr val="accent1"/>
+          </a:fillRef>
+          <a:effectRef idx="2">
+            <a:schemeClr val="accent1"/>
+          </a:effectRef>
+          <a:fontRef idx="minor">
+            <a:schemeClr val="lt1"/>
+          </a:fontRef>
+        </p:style>
+        <p:txBody>
+          <a:bodyPr rtlCol="0" anchor="ctr"/>
+          <a:lstStyle/>
+          <a:p>
+            <a:pPr algn="ctr"/>
+          </a:p>
+        </p:txBody>
+      </p:sp>
+      <p:sp>
+        <p:nvSpPr>
+          <p:cNvPr id="20" name="TextBox 19"/>
+          <p:cNvSpPr txBox="1"/>
+          <p:nvPr/>
+        </p:nvSpPr>
+        <p:spPr>
+          <a:xfrm>
+            <a:off x="3520440" y="2971800"/>
+            <a:ext cx="2331720" cy="502920"/>
+          </a:xfrm>
+          <a:prstGeom prst="rect">
+            <a:avLst/>
+          </a:prstGeom>
+          <a:noFill/>
+        </p:spPr>
+        <p:txBody>
+          <a:bodyPr wrap="square" lIns="45720" rIns="45720" tIns="18288" bIns="18288" anchor="t">
+            <a:spAutoFit/>
+          </a:bodyPr>
+          <a:lstStyle/>
+          <a:p>
+            <a:pPr algn="ctr">
+              <a:lnSpc>
+                <a:spcPct val="120000"/>
+              </a:lnSpc>
+            </a:pPr>
+            <a:r>
+              <a:rPr sz="2200" b="1">
+                <a:solidFill>
+                  <a:srgbClr val="2563EB"/>
+                </a:solidFill>
+                <a:latin typeface="Apple SD Gothic Neo"/>
+                <a:ea typeface="Apple SD Gothic Neo"/>
+                <a:cs typeface="Apple SD Gothic Neo"/>
+              </a:rPr>
+              <a:t>+1.64 ~ +3.07%</a:t>
+            </a:r>
+          </a:p>
+        </p:txBody>
+      </p:sp>
+      <p:sp>
+        <p:nvSpPr>
+          <p:cNvPr id="21" name="TextBox 20"/>
+          <p:cNvSpPr txBox="1"/>
+          <p:nvPr/>
+        </p:nvSpPr>
+        <p:spPr>
+          <a:xfrm>
+            <a:off x="3520440" y="3474720"/>
+            <a:ext cx="2331720" cy="365760"/>
+          </a:xfrm>
+          <a:prstGeom prst="rect">
+            <a:avLst/>
+          </a:prstGeom>
+          <a:noFill/>
+        </p:spPr>
+        <p:txBody>
+          <a:bodyPr wrap="square" lIns="45720" rIns="45720" tIns="18288" bIns="18288" anchor="t">
+            <a:spAutoFit/>
+          </a:bodyPr>
+          <a:lstStyle/>
+          <a:p>
+            <a:pPr algn="ctr">
+              <a:lnSpc>
+                <a:spcPct val="130000"/>
+              </a:lnSpc>
+            </a:pPr>
+            <a:r>
+              <a:rPr sz="800" b="0">
+                <a:solidFill>
+                  <a:srgbClr val="64748B"/>
+                </a:solidFill>
+                <a:latin typeface="Apple SD Gothic Neo"/>
+                <a:ea typeface="Apple SD Gothic Neo"/>
+                <a:cs typeface="Apple SD Gothic Neo"/>
+              </a:rPr>
+              <a:t>DEEP 1M / 8M / SIFT 5-seed 95% CI</a:t>
+            </a:r>
+          </a:p>
+        </p:txBody>
+      </p:sp>
+      <p:sp>
+        <p:nvSpPr>
+          <p:cNvPr id="22" name="TextBox 21"/>
+          <p:cNvSpPr txBox="1"/>
+          <p:nvPr/>
+        </p:nvSpPr>
+        <p:spPr>
+          <a:xfrm>
+            <a:off x="3520440" y="4023360"/>
+            <a:ext cx="2377440" cy="1417320"/>
+          </a:xfrm>
+          <a:prstGeom prst="rect">
+            <a:avLst/>
+          </a:prstGeom>
+          <a:noFill/>
+        </p:spPr>
+        <p:txBody>
+          <a:bodyPr wrap="square" lIns="45720" rIns="45720" tIns="18288" bIns="18288" anchor="t">
+            <a:spAutoFit/>
+          </a:bodyPr>
+          <a:lstStyle/>
+          <a:p>
+            <a:pPr algn="l">
+              <a:lnSpc>
+                <a:spcPct val="140000"/>
+              </a:lnSpc>
+            </a:pPr>
+            <a:r>
+              <a:rPr sz="900" b="0">
+                <a:solidFill>
+                  <a:srgbClr val="0F172A"/>
+                </a:solidFill>
+                <a:latin typeface="Apple SD Gothic Neo"/>
+                <a:ea typeface="Apple SD Gothic Neo"/>
+                <a:cs typeface="Apple SD Gothic Neo"/>
+              </a:rPr>
+              <a:t>3 데이터셋 모두 BERN 위에서 추가 개선 — DEEP 1M vs 8M CI 겹침 (CONSISTENT) · SIFT 1.5M 약 2배 효과 (CV 0.394, 통계적 구별)</a:t>
+            </a:r>
+          </a:p>
+        </p:txBody>
+      </p:sp>
+      <p:sp>
+        <p:nvSpPr>
+          <p:cNvPr id="23" name="Rounded Rectangle 22"/>
+          <p:cNvSpPr/>
+          <p:nvPr/>
+        </p:nvSpPr>
+        <p:spPr>
+          <a:xfrm>
+            <a:off x="6126479" y="1417320"/>
+            <a:ext cx="2697480" cy="4114800"/>
+          </a:xfrm>
+          <a:prstGeom prst="roundRect">
+            <a:avLst>
+              <a:gd name="adj" fmla="val 8000"/>
+            </a:avLst>
+          </a:prstGeom>
+          <a:solidFill>
+            <a:srgbClr val="F8FAFC"/>
+          </a:solidFill>
+          <a:ln w="9525">
+            <a:solidFill>
+              <a:srgbClr val="E2E8F0"/>
+            </a:solidFill>
+          </a:ln>
+          <a:effectLst/>
+        </p:spPr>
+        <p:style>
+          <a:lnRef idx="1">
+            <a:schemeClr val="accent1"/>
+          </a:lnRef>
+          <a:fillRef idx="3">
+            <a:schemeClr val="accent1"/>
+          </a:fillRef>
+          <a:effectRef idx="2">
+            <a:schemeClr val="accent1"/>
+          </a:effectRef>
+          <a:fontRef idx="minor">
+            <a:schemeClr val="lt1"/>
+          </a:fontRef>
+        </p:style>
+        <p:txBody>
+          <a:bodyPr rtlCol="0" anchor="ctr"/>
+          <a:lstStyle/>
+          <a:p>
+            <a:pPr algn="ctr"/>
+          </a:p>
+        </p:txBody>
+      </p:sp>
+      <p:sp>
+        <p:nvSpPr>
+          <p:cNvPr id="24" name="Rectangle 23"/>
+          <p:cNvSpPr/>
+          <p:nvPr/>
+        </p:nvSpPr>
+        <p:spPr>
+          <a:xfrm>
+            <a:off x="6126479" y="1417320"/>
+            <a:ext cx="2697480" cy="502920"/>
+          </a:xfrm>
+          <a:prstGeom prst="rect">
+            <a:avLst/>
+          </a:prstGeom>
+          <a:solidFill>
+            <a:srgbClr val="2563EB"/>
+          </a:solidFill>
+          <a:ln>
+            <a:noFill/>
+          </a:ln>
+          <a:effectLst/>
+        </p:spPr>
+        <p:style>
+          <a:lnRef idx="1">
+            <a:schemeClr val="accent1"/>
+          </a:lnRef>
+          <a:fillRef idx="3">
+            <a:schemeClr val="accent1"/>
+          </a:fillRef>
+          <a:effectRef idx="2">
+            <a:schemeClr val="accent1"/>
+          </a:effectRef>
+          <a:fontRef idx="minor">
+            <a:schemeClr val="lt1"/>
+          </a:fontRef>
+        </p:style>
+        <p:txBody>
+          <a:bodyPr rtlCol="0" anchor="ctr"/>
+          <a:lstStyle/>
+          <a:p>
+            <a:pPr algn="ctr"/>
+          </a:p>
+        </p:txBody>
+      </p:sp>
+      <p:sp>
+        <p:nvSpPr>
+          <p:cNvPr id="25" name="TextBox 24"/>
+          <p:cNvSpPr txBox="1"/>
+          <p:nvPr/>
+        </p:nvSpPr>
+        <p:spPr>
+          <a:xfrm>
+            <a:off x="6309359" y="1508760"/>
+            <a:ext cx="2377440" cy="365760"/>
+          </a:xfrm>
+          <a:prstGeom prst="rect">
+            <a:avLst/>
+          </a:prstGeom>
+          <a:noFill/>
+        </p:spPr>
+        <p:txBody>
+          <a:bodyPr wrap="square" lIns="45720" rIns="45720" tIns="18288" bIns="18288" anchor="t">
+            <a:spAutoFit/>
+          </a:bodyPr>
+          <a:lstStyle/>
+          <a:p>
+            <a:pPr algn="l">
+              <a:lnSpc>
+                <a:spcPct val="120000"/>
+              </a:lnSpc>
+            </a:pPr>
+            <a:r>
+              <a:rPr sz="1400" b="1">
+                <a:solidFill>
+                  <a:srgbClr val="FFFFFF"/>
+                </a:solidFill>
+                <a:latin typeface="Apple SD Gothic Neo"/>
+                <a:ea typeface="Apple SD Gothic Neo"/>
+                <a:cs typeface="Apple SD Gothic Neo"/>
+              </a:rPr>
+              <a:t>Two-Level</a:t>
+            </a:r>
+          </a:p>
+        </p:txBody>
+      </p:sp>
+      <p:sp>
+        <p:nvSpPr>
+          <p:cNvPr id="26" name="TextBox 25"/>
+          <p:cNvSpPr txBox="1"/>
+          <p:nvPr/>
+        </p:nvSpPr>
+        <p:spPr>
+          <a:xfrm>
+            <a:off x="6309359" y="2057400"/>
+            <a:ext cx="2377440" cy="777240"/>
+          </a:xfrm>
+          <a:prstGeom prst="rect">
+            <a:avLst/>
+          </a:prstGeom>
+          <a:noFill/>
+        </p:spPr>
+        <p:txBody>
+          <a:bodyPr wrap="square" lIns="45720" rIns="45720" tIns="18288" bIns="18288" anchor="t">
+            <a:spAutoFit/>
+          </a:bodyPr>
+          <a:lstStyle/>
+          <a:p>
+            <a:pPr algn="l">
+              <a:lnSpc>
+                <a:spcPct val="130000"/>
+              </a:lnSpc>
+            </a:pPr>
+            <a:r>
+              <a:rPr sz="1200" b="1">
+                <a:solidFill>
+                  <a:srgbClr val="0F172A"/>
+                </a:solidFill>
+                <a:latin typeface="Apple SD Gothic Neo"/>
+                <a:ea typeface="Apple SD Gothic Neo"/>
+                <a:cs typeface="Apple SD Gothic Neo"/>
+              </a:rPr>
+              <a:t>공간 인식 단독 효과 정량화</a:t>
+            </a:r>
+          </a:p>
+        </p:txBody>
+      </p:sp>
+      <p:sp>
+        <p:nvSpPr>
+          <p:cNvPr id="27" name="Rounded Rectangle 26"/>
+          <p:cNvSpPr/>
+          <p:nvPr/>
+        </p:nvSpPr>
+        <p:spPr>
+          <a:xfrm>
+            <a:off x="6309359" y="2926080"/>
+            <a:ext cx="2331720" cy="960120"/>
+          </a:xfrm>
+          <a:prstGeom prst="roundRect">
+            <a:avLst>
+              <a:gd name="adj" fmla="val 8000"/>
+            </a:avLst>
+          </a:prstGeom>
+          <a:solidFill>
+            <a:srgbClr val="FFFFFF"/>
+          </a:solidFill>
+          <a:ln w="19050">
+            <a:solidFill>
+              <a:srgbClr val="3B82F6"/>
+            </a:solidFill>
+          </a:ln>
+          <a:effectLst/>
+        </p:spPr>
+        <p:style>
+          <a:lnRef idx="1">
+            <a:schemeClr val="accent1"/>
+          </a:lnRef>
+          <a:fillRef idx="3">
+            <a:schemeClr val="accent1"/>
+          </a:fillRef>
+          <a:effectRef idx="2">
+            <a:schemeClr val="accent1"/>
+          </a:effectRef>
+          <a:fontRef idx="minor">
+            <a:schemeClr val="lt1"/>
+          </a:fontRef>
+        </p:style>
+        <p:txBody>
+          <a:bodyPr rtlCol="0" anchor="ctr"/>
+          <a:lstStyle/>
+          <a:p>
+            <a:pPr algn="ctr"/>
+          </a:p>
+        </p:txBody>
+      </p:sp>
+      <p:sp>
+        <p:nvSpPr>
+          <p:cNvPr id="28" name="TextBox 27"/>
+          <p:cNvSpPr txBox="1"/>
+          <p:nvPr/>
+        </p:nvSpPr>
+        <p:spPr>
+          <a:xfrm>
+            <a:off x="6309359" y="2971800"/>
+            <a:ext cx="2331720" cy="502920"/>
+          </a:xfrm>
+          <a:prstGeom prst="rect">
+            <a:avLst/>
+          </a:prstGeom>
+          <a:noFill/>
+        </p:spPr>
+        <p:txBody>
+          <a:bodyPr wrap="square" lIns="45720" rIns="45720" tIns="18288" bIns="18288" anchor="t">
+            <a:spAutoFit/>
+          </a:bodyPr>
+          <a:lstStyle/>
+          <a:p>
+            <a:pPr algn="ctr">
+              <a:lnSpc>
+                <a:spcPct val="120000"/>
+              </a:lnSpc>
+            </a:pPr>
+            <a:r>
+              <a:rPr sz="2200" b="1">
+                <a:solidFill>
+                  <a:srgbClr val="2563EB"/>
+                </a:solidFill>
+                <a:latin typeface="Apple SD Gothic Neo"/>
+                <a:ea typeface="Apple SD Gothic Neo"/>
+                <a:cs typeface="Apple SD Gothic Neo"/>
+              </a:rPr>
+              <a:t>+19.6 %p</a:t>
+            </a:r>
+          </a:p>
+        </p:txBody>
+      </p:sp>
+      <p:sp>
+        <p:nvSpPr>
+          <p:cNvPr id="29" name="TextBox 28"/>
+          <p:cNvSpPr txBox="1"/>
+          <p:nvPr/>
+        </p:nvSpPr>
+        <p:spPr>
+          <a:xfrm>
+            <a:off x="6309359" y="3474720"/>
+            <a:ext cx="2331720" cy="365760"/>
+          </a:xfrm>
+          <a:prstGeom prst="rect">
+            <a:avLst/>
+          </a:prstGeom>
+          <a:noFill/>
+        </p:spPr>
+        <p:txBody>
+          <a:bodyPr wrap="square" lIns="45720" rIns="45720" tIns="18288" bIns="18288" anchor="t">
+            <a:spAutoFit/>
+          </a:bodyPr>
+          <a:lstStyle/>
+          <a:p>
+            <a:pPr algn="ctr">
+              <a:lnSpc>
+                <a:spcPct val="130000"/>
+              </a:lnSpc>
+            </a:pPr>
+            <a:r>
+              <a:rPr sz="800" b="0">
+                <a:solidFill>
+                  <a:srgbClr val="64748B"/>
+                </a:solidFill>
+                <a:latin typeface="Apple SD Gothic Neo"/>
+                <a:ea typeface="Apple SD Gothic Neo"/>
+                <a:cs typeface="Apple SD Gothic Neo"/>
+              </a:rPr>
+              <a:t>Level 2 단독 (DEEP 1M, s=0.010)</a:t>
+            </a:r>
+          </a:p>
+        </p:txBody>
+      </p:sp>
+      <p:sp>
+        <p:nvSpPr>
+          <p:cNvPr id="30" name="TextBox 29"/>
+          <p:cNvSpPr txBox="1"/>
+          <p:nvPr/>
+        </p:nvSpPr>
+        <p:spPr>
+          <a:xfrm>
+            <a:off x="6309359" y="4023360"/>
+            <a:ext cx="2377440" cy="1417320"/>
+          </a:xfrm>
+          <a:prstGeom prst="rect">
+            <a:avLst/>
+          </a:prstGeom>
+          <a:noFill/>
+        </p:spPr>
+        <p:txBody>
+          <a:bodyPr wrap="square" lIns="45720" rIns="45720" tIns="18288" bIns="18288" anchor="t">
+            <a:spAutoFit/>
+          </a:bodyPr>
+          <a:lstStyle/>
+          <a:p>
+            <a:pPr algn="l">
+              <a:lnSpc>
+                <a:spcPct val="140000"/>
+              </a:lnSpc>
+            </a:pPr>
+            <a:r>
+              <a:rPr sz="900" b="0">
+                <a:solidFill>
+                  <a:srgbClr val="0F172A"/>
+                </a:solidFill>
+                <a:latin typeface="Apple SD Gothic Neo"/>
+                <a:ea typeface="Apple SD Gothic Neo"/>
+                <a:cs typeface="Apple SD Gothic Neo"/>
+              </a:rPr>
+              <a:t>KM20 +8.93%, RANDOM20 −10.67% — 비례 배분 (Level 1) 과 공간 인식 (Level 2) 분해, 가설 단조 관계 재확인 (Horvitz-Thompson 1952)</a:t>
+            </a:r>
+          </a:p>
+        </p:txBody>
+      </p:sp>
+      <p:sp>
+        <p:nvSpPr>
+          <p:cNvPr id="31" name="Rounded Rectangle 30"/>
+          <p:cNvSpPr/>
+          <p:nvPr/>
+        </p:nvSpPr>
+        <p:spPr>
+          <a:xfrm>
+            <a:off x="8915399" y="1417320"/>
+            <a:ext cx="2697480" cy="4114800"/>
+          </a:xfrm>
+          <a:prstGeom prst="roundRect">
+            <a:avLst>
+              <a:gd name="adj" fmla="val 8000"/>
+            </a:avLst>
+          </a:prstGeom>
+          <a:solidFill>
+            <a:srgbClr val="F8FAFC"/>
+          </a:solidFill>
+          <a:ln w="9525">
+            <a:solidFill>
+              <a:srgbClr val="E2E8F0"/>
+            </a:solidFill>
+          </a:ln>
+          <a:effectLst/>
+        </p:spPr>
+        <p:style>
+          <a:lnRef idx="1">
+            <a:schemeClr val="accent1"/>
+          </a:lnRef>
+          <a:fillRef idx="3">
+            <a:schemeClr val="accent1"/>
+          </a:fillRef>
+          <a:effectRef idx="2">
+            <a:schemeClr val="accent1"/>
+          </a:effectRef>
+          <a:fontRef idx="minor">
+            <a:schemeClr val="lt1"/>
+          </a:fontRef>
+        </p:style>
+        <p:txBody>
+          <a:bodyPr rtlCol="0" anchor="ctr"/>
+          <a:lstStyle/>
+          <a:p>
+            <a:pPr algn="ctr"/>
+          </a:p>
+        </p:txBody>
+      </p:sp>
+      <p:sp>
+        <p:nvSpPr>
+          <p:cNvPr id="32" name="Rectangle 31"/>
+          <p:cNvSpPr/>
+          <p:nvPr/>
+        </p:nvSpPr>
+        <p:spPr>
+          <a:xfrm>
+            <a:off x="8915399" y="1417320"/>
+            <a:ext cx="2697480" cy="502920"/>
+          </a:xfrm>
+          <a:prstGeom prst="rect">
+            <a:avLst/>
+          </a:prstGeom>
+          <a:solidFill>
+            <a:srgbClr val="2563EB"/>
+          </a:solidFill>
+          <a:ln>
+            <a:noFill/>
+          </a:ln>
+          <a:effectLst/>
+        </p:spPr>
+        <p:style>
+          <a:lnRef idx="1">
+            <a:schemeClr val="accent1"/>
+          </a:lnRef>
+          <a:fillRef idx="3">
+            <a:schemeClr val="accent1"/>
+          </a:fillRef>
+          <a:effectRef idx="2">
+            <a:schemeClr val="accent1"/>
+          </a:effectRef>
+          <a:fontRef idx="minor">
+            <a:schemeClr val="lt1"/>
+          </a:fontRef>
+        </p:style>
+        <p:txBody>
+          <a:bodyPr rtlCol="0" anchor="ctr"/>
+          <a:lstStyle/>
+          <a:p>
+            <a:pPr algn="ctr"/>
+          </a:p>
+        </p:txBody>
+      </p:sp>
+      <p:sp>
+        <p:nvSpPr>
+          <p:cNvPr id="33" name="TextBox 32"/>
+          <p:cNvSpPr txBox="1"/>
+          <p:nvPr/>
+        </p:nvSpPr>
+        <p:spPr>
+          <a:xfrm>
+            <a:off x="9098279" y="1508760"/>
+            <a:ext cx="2377440" cy="365760"/>
+          </a:xfrm>
+          <a:prstGeom prst="rect">
+            <a:avLst/>
+          </a:prstGeom>
+          <a:noFill/>
+        </p:spPr>
+        <p:txBody>
+          <a:bodyPr wrap="square" lIns="45720" rIns="45720" tIns="18288" bIns="18288" anchor="t">
+            <a:spAutoFit/>
+          </a:bodyPr>
+          <a:lstStyle/>
+          <a:p>
+            <a:pPr algn="l">
+              <a:lnSpc>
+                <a:spcPct val="120000"/>
+              </a:lnSpc>
+            </a:pPr>
+            <a:r>
+              <a:rPr sz="1400" b="1">
+                <a:solidFill>
+                  <a:srgbClr val="FFFFFF"/>
+                </a:solidFill>
+                <a:latin typeface="Apple SD Gothic Neo"/>
+                <a:ea typeface="Apple SD Gothic Neo"/>
+                <a:cs typeface="Apple SD Gothic Neo"/>
+              </a:rPr>
+              <a:t>RQ3</a:t>
+            </a:r>
+          </a:p>
+        </p:txBody>
+      </p:sp>
+      <p:sp>
+        <p:nvSpPr>
+          <p:cNvPr id="34" name="TextBox 33"/>
+          <p:cNvSpPr txBox="1"/>
+          <p:nvPr/>
+        </p:nvSpPr>
+        <p:spPr>
+          <a:xfrm>
+            <a:off x="9098279" y="2057400"/>
+            <a:ext cx="2377440" cy="777240"/>
+          </a:xfrm>
+          <a:prstGeom prst="rect">
+            <a:avLst/>
+          </a:prstGeom>
+          <a:noFill/>
+        </p:spPr>
+        <p:txBody>
+          <a:bodyPr wrap="square" lIns="45720" rIns="45720" tIns="18288" bIns="18288" anchor="t">
+            <a:spAutoFit/>
+          </a:bodyPr>
+          <a:lstStyle/>
+          <a:p>
+            <a:pPr algn="l">
+              <a:lnSpc>
+                <a:spcPct val="130000"/>
+              </a:lnSpc>
+            </a:pPr>
+            <a:r>
+              <a:rPr sz="1200" b="1">
+                <a:solidFill>
+                  <a:srgbClr val="0F172A"/>
+                </a:solidFill>
+                <a:latin typeface="Apple SD Gothic Neo"/>
+                <a:ea typeface="Apple SD Gothic Neo"/>
+                <a:cs typeface="Apple SD Gothic Neo"/>
+              </a:rPr>
+              <a:t>Recovery Rate 프레임워크 설계 완료</a:t>
+            </a:r>
+          </a:p>
+        </p:txBody>
+      </p:sp>
+      <p:sp>
+        <p:nvSpPr>
+          <p:cNvPr id="35" name="Rounded Rectangle 34"/>
+          <p:cNvSpPr/>
+          <p:nvPr/>
+        </p:nvSpPr>
+        <p:spPr>
+          <a:xfrm>
+            <a:off x="9098279" y="2926080"/>
+            <a:ext cx="2331720" cy="960120"/>
+          </a:xfrm>
+          <a:prstGeom prst="roundRect">
+            <a:avLst>
+              <a:gd name="adj" fmla="val 8000"/>
+            </a:avLst>
+          </a:prstGeom>
+          <a:solidFill>
+            <a:srgbClr val="FFFFFF"/>
+          </a:solidFill>
+          <a:ln w="19050">
+            <a:solidFill>
+              <a:srgbClr val="3B82F6"/>
+            </a:solidFill>
+          </a:ln>
+          <a:effectLst/>
+        </p:spPr>
+        <p:style>
+          <a:lnRef idx="1">
+            <a:schemeClr val="accent1"/>
+          </a:lnRef>
+          <a:fillRef idx="3">
+            <a:schemeClr val="accent1"/>
+          </a:fillRef>
+          <a:effectRef idx="2">
+            <a:schemeClr val="accent1"/>
+          </a:effectRef>
+          <a:fontRef idx="minor">
+            <a:schemeClr val="lt1"/>
+          </a:fontRef>
+        </p:style>
+        <p:txBody>
+          <a:bodyPr rtlCol="0" anchor="ctr"/>
+          <a:lstStyle/>
+          <a:p>
+            <a:pPr algn="ctr"/>
+          </a:p>
+        </p:txBody>
+      </p:sp>
+      <p:sp>
+        <p:nvSpPr>
+          <p:cNvPr id="36" name="TextBox 35"/>
+          <p:cNvSpPr txBox="1"/>
+          <p:nvPr/>
+        </p:nvSpPr>
+        <p:spPr>
+          <a:xfrm>
+            <a:off x="9098279" y="2971800"/>
+            <a:ext cx="2331720" cy="502920"/>
+          </a:xfrm>
+          <a:prstGeom prst="rect">
+            <a:avLst/>
+          </a:prstGeom>
+          <a:noFill/>
+        </p:spPr>
+        <p:txBody>
+          <a:bodyPr wrap="square" lIns="45720" rIns="45720" tIns="18288" bIns="18288" anchor="t">
+            <a:spAutoFit/>
+          </a:bodyPr>
+          <a:lstStyle/>
+          <a:p>
+            <a:pPr algn="ctr">
+              <a:lnSpc>
+                <a:spcPct val="120000"/>
+              </a:lnSpc>
+            </a:pPr>
+            <a:r>
+              <a:rPr sz="2200" b="1">
+                <a:solidFill>
+                  <a:srgbClr val="2563EB"/>
+                </a:solidFill>
+                <a:latin typeface="Apple SD Gothic Neo"/>
+                <a:ea typeface="Apple SD Gothic Neo"/>
+                <a:cs typeface="Apple SD Gothic Neo"/>
+              </a:rPr>
+              <a:t>3 × 7</a:t>
+            </a:r>
+          </a:p>
+        </p:txBody>
+      </p:sp>
+      <p:sp>
+        <p:nvSpPr>
+          <p:cNvPr id="37" name="TextBox 36"/>
+          <p:cNvSpPr txBox="1"/>
+          <p:nvPr/>
+        </p:nvSpPr>
+        <p:spPr>
+          <a:xfrm>
+            <a:off x="9098279" y="3474720"/>
+            <a:ext cx="2331720" cy="365760"/>
+          </a:xfrm>
+          <a:prstGeom prst="rect">
+            <a:avLst/>
+          </a:prstGeom>
+          <a:noFill/>
+        </p:spPr>
+        <p:txBody>
+          <a:bodyPr wrap="square" lIns="45720" rIns="45720" tIns="18288" bIns="18288" anchor="t">
+            <a:spAutoFit/>
+          </a:bodyPr>
+          <a:lstStyle/>
+          <a:p>
+            <a:pPr algn="ctr">
+              <a:lnSpc>
+                <a:spcPct val="130000"/>
+              </a:lnSpc>
+            </a:pPr>
+            <a:r>
+              <a:rPr sz="800" b="0">
+                <a:solidFill>
+                  <a:srgbClr val="64748B"/>
+                </a:solidFill>
+                <a:latin typeface="Apple SD Gothic Neo"/>
+                <a:ea typeface="Apple SD Gothic Neo"/>
+                <a:cs typeface="Apple SD Gothic Neo"/>
+              </a:rPr>
+              <a:t>패러다임 × 방법 (W5~W7 실험)</a:t>
+            </a:r>
+          </a:p>
+        </p:txBody>
+      </p:sp>
+      <p:sp>
+        <p:nvSpPr>
+          <p:cNvPr id="38" name="TextBox 37"/>
+          <p:cNvSpPr txBox="1"/>
+          <p:nvPr/>
+        </p:nvSpPr>
+        <p:spPr>
+          <a:xfrm>
+            <a:off x="9098279" y="4023360"/>
+            <a:ext cx="2377440" cy="1417320"/>
+          </a:xfrm>
+          <a:prstGeom prst="rect">
+            <a:avLst/>
+          </a:prstGeom>
+          <a:noFill/>
+        </p:spPr>
+        <p:txBody>
+          <a:bodyPr wrap="square" lIns="45720" rIns="45720" tIns="18288" bIns="18288" anchor="t">
+            <a:spAutoFit/>
+          </a:bodyPr>
+          <a:lstStyle/>
+          <a:p>
+            <a:pPr algn="l">
+              <a:lnSpc>
+                <a:spcPct val="140000"/>
+              </a:lnSpc>
+            </a:pPr>
+            <a:r>
+              <a:rPr sz="900" b="0">
+                <a:solidFill>
+                  <a:srgbClr val="0F172A"/>
+                </a:solidFill>
+                <a:latin typeface="Apple SD Gothic Neo"/>
+                <a:ea typeface="Apple SD Gothic Neo"/>
+                <a:cs typeface="Apple SD Gothic Neo"/>
+              </a:rPr>
+              <a:t>Offline (LSH/RP/Hilbert/MiniBatch) + Online (Shell/KDE-pilot) + Weight (IS) — 분포 미지 시 KM20 의 절반 효과 회수 목표 (Neyman 1934)</a:t>
+            </a:r>
+          </a:p>
+        </p:txBody>
+      </p:sp>
+      <p:sp>
+        <p:nvSpPr>
+          <p:cNvPr id="39" name="Rounded Rectangle 38"/>
+          <p:cNvSpPr/>
+          <p:nvPr/>
+        </p:nvSpPr>
+        <p:spPr>
+          <a:xfrm>
+            <a:off x="548640" y="5669280"/>
+            <a:ext cx="11064240" cy="502920"/>
+          </a:xfrm>
+          <a:prstGeom prst="roundRect">
+            <a:avLst>
+              <a:gd name="adj" fmla="val 8000"/>
+            </a:avLst>
+          </a:prstGeom>
+          <a:solidFill>
+            <a:srgbClr val="0F172A"/>
+          </a:solidFill>
+          <a:ln>
+            <a:noFill/>
+          </a:ln>
+          <a:effectLst/>
+        </p:spPr>
+        <p:style>
+          <a:lnRef idx="1">
+            <a:schemeClr val="accent1"/>
+          </a:lnRef>
+          <a:fillRef idx="3">
+            <a:schemeClr val="accent1"/>
+          </a:fillRef>
+          <a:effectRef idx="2">
+            <a:schemeClr val="accent1"/>
+          </a:effectRef>
+          <a:fontRef idx="minor">
+            <a:schemeClr val="lt1"/>
+          </a:fontRef>
+        </p:style>
+        <p:txBody>
+          <a:bodyPr rtlCol="0" anchor="ctr"/>
+          <a:lstStyle/>
+          <a:p>
+            <a:pPr algn="ctr"/>
+          </a:p>
+        </p:txBody>
+      </p:sp>
+      <p:sp>
+        <p:nvSpPr>
+          <p:cNvPr id="40" name="TextBox 39"/>
+          <p:cNvSpPr txBox="1"/>
+          <p:nvPr/>
+        </p:nvSpPr>
+        <p:spPr>
+          <a:xfrm>
+            <a:off x="777240" y="5715000"/>
+            <a:ext cx="10515600" cy="411480"/>
+          </a:xfrm>
+          <a:prstGeom prst="rect">
+            <a:avLst/>
+          </a:prstGeom>
+          <a:noFill/>
+        </p:spPr>
+        <p:txBody>
+          <a:bodyPr wrap="square" lIns="45720" rIns="45720" tIns="18288" bIns="18288" anchor="ctr">
+            <a:spAutoFit/>
+          </a:bodyPr>
+          <a:lstStyle/>
+          <a:p>
+            <a:pPr algn="l">
+              <a:lnSpc>
+                <a:spcPct val="120000"/>
+              </a:lnSpc>
+            </a:pPr>
+            <a:r>
+              <a:rPr sz="1100" b="1">
+                <a:solidFill>
+                  <a:srgbClr val="3B82F6"/>
+                </a:solidFill>
+                <a:latin typeface="Apple SD Gothic Neo"/>
+                <a:ea typeface="Apple SD Gothic Neo"/>
+                <a:cs typeface="Apple SD Gothic Neo"/>
+              </a:rPr>
+              <a:t>★  skewed 거리 분포에서 카디널리티 추정 정확도 — 본 연구의 단계적 sanitize 가 측정 가능한 개선을 정량 확보</a:t>
+            </a:r>
+          </a:p>
+        </p:txBody>
+      </p:sp>
+    </p:spTree>
+  </p:cSld>
+  <p:clrMapOvr>
+    <a:masterClrMapping/>
+  </p:clrMapOvr>
+</p:sld>
+</file>
+
+<file path=ppt/slides/slide17.xml><?xml version="1.0" encoding="utf-8"?>
 <p:sld xmlns:a="http://schemas.openxmlformats.org/drawingml/2006/main" xmlns:p="http://schemas.openxmlformats.org/presentationml/2006/main" xmlns:r="http://schemas.openxmlformats.org/officeDocument/2006/relationships">
   <p:cSld>
     <p:bg>
@@ -12441,7 +15660,7 @@
                 <a:ea typeface="Apple SD Gothic Neo"/>
                 <a:cs typeface="Apple SD Gothic Neo"/>
               </a:rPr>
-              <a:t>2 / 16</a:t>
+              <a:t>2 / 17</a:t>
             </a:r>
           </a:p>
         </p:txBody>
@@ -13482,7 +16701,7 @@
                 <a:ea typeface="Apple SD Gothic Neo"/>
                 <a:cs typeface="Apple SD Gothic Neo"/>
               </a:rPr>
-              <a:t>3 / 16</a:t>
+              <a:t>3 / 17</a:t>
             </a:r>
           </a:p>
         </p:txBody>
@@ -14228,7 +17447,7 @@
                 <a:ea typeface="Apple SD Gothic Neo"/>
                 <a:cs typeface="Apple SD Gothic Neo"/>
               </a:rPr>
-              <a:t>■ 옵티마이저가 잘못된 실행 계획 선택 → nested loop ↔ hash join, index 사용 여부</a:t>
+              <a:t>■ 옵티마이저가 잘못된 실행 계획 선택 → nested loop vs hash join, index 사용 여부</a:t>
             </a:r>
           </a:p>
           <a:p>
@@ -14573,7 +17792,7 @@
                 <a:ea typeface="Apple SD Gothic Neo"/>
                 <a:cs typeface="Apple SD Gothic Neo"/>
               </a:rPr>
-              <a:t>4 / 16</a:t>
+              <a:t>4 / 17</a:t>
             </a:r>
           </a:p>
         </p:txBody>
@@ -15587,7 +18806,7 @@
                 <a:ea typeface="Apple SD Gothic Neo"/>
                 <a:cs typeface="Apple SD Gothic Neo"/>
               </a:rPr>
-              <a:t>5 / 16</a:t>
+              <a:t>5 / 17</a:t>
             </a:r>
           </a:p>
         </p:txBody>
@@ -16785,7 +20004,7 @@
                 <a:ea typeface="Apple SD Gothic Neo"/>
                 <a:cs typeface="Apple SD Gothic Neo"/>
               </a:rPr>
-              <a:t>6 / 16</a:t>
+              <a:t>6 / 17</a:t>
             </a:r>
           </a:p>
         </p:txBody>
@@ -18146,7 +21365,7 @@
                 <a:ea typeface="Apple SD Gothic Neo"/>
                 <a:cs typeface="Apple SD Gothic Neo"/>
               </a:rPr>
-              <a:t>7 / 16</a:t>
+              <a:t>7 / 17</a:t>
             </a:r>
           </a:p>
         </p:txBody>
@@ -19117,7 +22336,7 @@
                 <a:ea typeface="Apple SD Gothic Neo"/>
                 <a:cs typeface="Apple SD Gothic Neo"/>
               </a:rPr>
-              <a:t>8 / 16</a:t>
+              <a:t>8 / 17</a:t>
             </a:r>
           </a:p>
         </p:txBody>
@@ -19132,7 +22351,7 @@
         </p:nvGraphicFramePr>
         <p:xfrm>
           <a:off x="548640" y="1417320"/>
-          <a:ext cx="7315200" cy="2231136"/>
+          <a:ext cx="6217920" cy="2487168"/>
         </p:xfrm>
         <a:graphic>
           <a:graphicData uri="http://schemas.openxmlformats.org/drawingml/2006/table">
@@ -19141,14 +22360,14 @@
                 <a:tableStyleId>{5C22544A-7EE6-4342-B048-85BDC9FD1C3A}</a:tableStyleId>
               </a:tblPr>
               <a:tblGrid>
-                <a:gridCol w="914400"/>
-                <a:gridCol w="1280160"/>
-                <a:gridCol w="1280160"/>
-                <a:gridCol w="914400"/>
-                <a:gridCol w="1463040"/>
-                <a:gridCol w="1463040"/>
+                <a:gridCol w="777240"/>
+                <a:gridCol w="1097280"/>
+                <a:gridCol w="1097280"/>
+                <a:gridCol w="777240"/>
+                <a:gridCol w="1234440"/>
+                <a:gridCol w="1234440"/>
               </a:tblGrid>
-              <a:tr h="318733">
+              <a:tr h="355309">
                 <a:tc>
                   <a:txBody>
                     <a:bodyPr/>
@@ -19288,7 +22507,7 @@
                   </a:tcPr>
                 </a:tc>
               </a:tr>
-              <a:tr h="318733">
+              <a:tr h="355309">
                 <a:tc>
                   <a:txBody>
                     <a:bodyPr/>
@@ -19428,7 +22647,7 @@
                   </a:tcPr>
                 </a:tc>
               </a:tr>
-              <a:tr h="318733">
+              <a:tr h="355309">
                 <a:tc>
                   <a:txBody>
                     <a:bodyPr/>
@@ -19568,7 +22787,7 @@
                   </a:tcPr>
                 </a:tc>
               </a:tr>
-              <a:tr h="318733">
+              <a:tr h="355309">
                 <a:tc>
                   <a:txBody>
                     <a:bodyPr/>
@@ -19708,7 +22927,7 @@
                   </a:tcPr>
                 </a:tc>
               </a:tr>
-              <a:tr h="318733">
+              <a:tr h="355309">
                 <a:tc>
                   <a:txBody>
                     <a:bodyPr/>
@@ -19848,7 +23067,7 @@
                   </a:tcPr>
                 </a:tc>
               </a:tr>
-              <a:tr h="318733">
+              <a:tr h="355309">
                 <a:tc>
                   <a:txBody>
                     <a:bodyPr/>
@@ -19988,7 +23207,7 @@
                   </a:tcPr>
                 </a:tc>
               </a:tr>
-              <a:tr h="318738">
+              <a:tr h="355314">
                 <a:tc>
                   <a:txBody>
                     <a:bodyPr/>
@@ -20132,16 +23351,81 @@
           </a:graphicData>
         </a:graphic>
       </p:graphicFrame>
-      <p:sp>
-        <p:nvSpPr>
-          <p:cNvPr id="8" name="TextBox 7"/>
-          <p:cNvSpPr txBox="1"/>
-          <p:nvPr/>
-        </p:nvSpPr>
-        <p:spPr>
-          <a:xfrm>
-            <a:off x="8092440" y="1417320"/>
-            <a:ext cx="3657600" cy="320040"/>
+      <p:pic>
+        <p:nvPicPr>
+          <p:cNvPr id="8" name="Picture 7" descr="figure_1_phase4_scatter.png"/>
+          <p:cNvPicPr>
+            <a:picLocks noChangeAspect="1"/>
+          </p:cNvPicPr>
+          <p:nvPr/>
+        </p:nvPicPr>
+        <p:blipFill>
+          <a:blip r:embed="rId2"/>
+          <a:stretch>
+            <a:fillRect/>
+          </a:stretch>
+        </p:blipFill>
+        <p:spPr>
+          <a:xfrm>
+            <a:off x="6858000" y="2680924"/>
+            <a:ext cx="4846320" cy="1313271"/>
+          </a:xfrm>
+          <a:prstGeom prst="rect">
+            <a:avLst/>
+          </a:prstGeom>
+        </p:spPr>
+      </p:pic>
+      <p:sp>
+        <p:nvSpPr>
+          <p:cNvPr id="9" name="TextBox 8"/>
+          <p:cNvSpPr txBox="1"/>
+          <p:nvPr/>
+        </p:nvSpPr>
+        <p:spPr>
+          <a:xfrm>
+            <a:off x="6858000" y="5303520"/>
+            <a:ext cx="4846320" cy="228600"/>
+          </a:xfrm>
+          <a:prstGeom prst="rect">
+            <a:avLst/>
+          </a:prstGeom>
+          <a:noFill/>
+        </p:spPr>
+        <p:txBody>
+          <a:bodyPr wrap="square" lIns="45720" rIns="45720" tIns="18288" bIns="18288" anchor="t">
+            <a:spAutoFit/>
+          </a:bodyPr>
+          <a:lstStyle/>
+          <a:p>
+            <a:pPr algn="ctr">
+              <a:lnSpc>
+                <a:spcPct val="120000"/>
+              </a:lnSpc>
+            </a:pPr>
+            <a:r>
+              <a:rPr sz="900" b="0">
+                <a:solidFill>
+                  <a:srgbClr val="64748B"/>
+                </a:solidFill>
+                <a:latin typeface="Apple SD Gothic Neo"/>
+                <a:ea typeface="Apple SD Gothic Neo"/>
+                <a:cs typeface="Apple SD Gothic Neo"/>
+              </a:rPr>
+              <a:t>Phase 4 — SYS vs BERN paired Q-error 4 panel (s=0.05/0.10/0.30/0.50)</a:t>
+            </a:r>
+          </a:p>
+        </p:txBody>
+      </p:sp>
+      <p:sp>
+        <p:nvSpPr>
+          <p:cNvPr id="10" name="TextBox 9"/>
+          <p:cNvSpPr txBox="1"/>
+          <p:nvPr/>
+        </p:nvSpPr>
+        <p:spPr>
+          <a:xfrm>
+            <a:off x="548640" y="4114800"/>
+            <a:ext cx="6309360" cy="292608"/>
           </a:xfrm>
           <a:prstGeom prst="rect">
             <a:avLst/>
@@ -20175,14 +23459,14 @@
       </p:sp>
       <p:sp>
         <p:nvSpPr>
-          <p:cNvPr id="9" name="Rounded Rectangle 8"/>
+          <p:cNvPr id="11" name="Rounded Rectangle 10"/>
           <p:cNvSpPr/>
           <p:nvPr/>
         </p:nvSpPr>
         <p:spPr>
           <a:xfrm>
-            <a:off x="8092440" y="1737360"/>
-            <a:ext cx="3611880" cy="1828800"/>
+            <a:off x="548640" y="4434840"/>
+            <a:ext cx="6263640" cy="1691640"/>
           </a:xfrm>
           <a:prstGeom prst="roundRect">
             <a:avLst>
@@ -20223,14 +23507,14 @@
       </p:sp>
       <p:sp>
         <p:nvSpPr>
-          <p:cNvPr id="10" name="TextBox 9"/>
-          <p:cNvSpPr txBox="1"/>
-          <p:nvPr/>
-        </p:nvSpPr>
-        <p:spPr>
-          <a:xfrm>
-            <a:off x="8229600" y="1828800"/>
-            <a:ext cx="3383280" cy="365760"/>
+          <p:cNvPr id="12" name="TextBox 11"/>
+          <p:cNvSpPr txBox="1"/>
+          <p:nvPr/>
+        </p:nvSpPr>
+        <p:spPr>
+          <a:xfrm>
+            <a:off x="713232" y="4526280"/>
+            <a:ext cx="6080760" cy="365760"/>
           </a:xfrm>
           <a:prstGeom prst="rect">
             <a:avLst/>
@@ -20249,7 +23533,7 @@
               </a:lnSpc>
             </a:pPr>
             <a:r>
-              <a:rPr sz="900" b="0">
+              <a:rPr sz="1000" b="0">
                 <a:solidFill>
                   <a:srgbClr val="0F172A"/>
                 </a:solidFill>
@@ -20266,11 +23550,11 @@
                 <a:spcPts val="0"/>
               </a:spcBef>
               <a:spcAft>
-                <a:spcPts val="500"/>
+                <a:spcPts val="600"/>
               </a:spcAft>
             </a:pPr>
             <a:r>
-              <a:rPr sz="900" b="0">
+              <a:rPr sz="1000" b="0">
                 <a:solidFill>
                   <a:srgbClr val="0F172A"/>
                 </a:solidFill>
@@ -20287,11 +23571,11 @@
                 <a:spcPts val="0"/>
               </a:spcBef>
               <a:spcAft>
-                <a:spcPts val="500"/>
+                <a:spcPts val="600"/>
               </a:spcAft>
             </a:pPr>
             <a:r>
-              <a:rPr sz="900" b="0">
+              <a:rPr sz="1000" b="0">
                 <a:solidFill>
                   <a:srgbClr val="0F172A"/>
                 </a:solidFill>
@@ -20300,71 +23584,6 @@
                 <a:cs typeface="Apple SD Gothic Neo"/>
               </a:rPr>
               <a:t>③  단, 이는 Pivot C 의 fair baseline 도구이지 단독 기여가 아님</a:t>
-            </a:r>
-          </a:p>
-        </p:txBody>
-      </p:sp>
-      <p:pic>
-        <p:nvPicPr>
-          <p:cNvPr id="11" name="Picture 10" descr="figure_1_phase4_scatter.png"/>
-          <p:cNvPicPr>
-            <a:picLocks noChangeAspect="1"/>
-          </p:cNvPicPr>
-          <p:nvPr/>
-        </p:nvPicPr>
-        <p:blipFill>
-          <a:blip r:embed="rId2"/>
-          <a:stretch>
-            <a:fillRect/>
-          </a:stretch>
-        </p:blipFill>
-        <p:spPr>
-          <a:xfrm>
-            <a:off x="2706381" y="4114800"/>
-            <a:ext cx="6748757" cy="1828800"/>
-          </a:xfrm>
-          <a:prstGeom prst="rect">
-            <a:avLst/>
-          </a:prstGeom>
-        </p:spPr>
-      </p:pic>
-      <p:sp>
-        <p:nvSpPr>
-          <p:cNvPr id="12" name="TextBox 11"/>
-          <p:cNvSpPr txBox="1"/>
-          <p:nvPr/>
-        </p:nvSpPr>
-        <p:spPr>
-          <a:xfrm>
-            <a:off x="548640" y="5989320"/>
-            <a:ext cx="11064240" cy="228600"/>
-          </a:xfrm>
-          <a:prstGeom prst="rect">
-            <a:avLst/>
-          </a:prstGeom>
-          <a:noFill/>
-        </p:spPr>
-        <p:txBody>
-          <a:bodyPr wrap="square" lIns="45720" rIns="45720" tIns="18288" bIns="18288" anchor="t">
-            <a:spAutoFit/>
-          </a:bodyPr>
-          <a:lstStyle/>
-          <a:p>
-            <a:pPr algn="ctr">
-              <a:lnSpc>
-                <a:spcPct val="120000"/>
-              </a:lnSpc>
-            </a:pPr>
-            <a:r>
-              <a:rPr sz="900" b="0">
-                <a:solidFill>
-                  <a:srgbClr val="64748B"/>
-                </a:solidFill>
-                <a:latin typeface="Apple SD Gothic Neo"/>
-                <a:ea typeface="Apple SD Gothic Neo"/>
-                <a:cs typeface="Apple SD Gothic Neo"/>
-              </a:rPr>
-              <a:t>Phase 4 — SYS vs BERN paired Q-error 4 panel (s=0.05/0.10/0.30/0.50)</a:t>
             </a:r>
           </a:p>
         </p:txBody>
@@ -20601,7 +23820,7 @@
                 <a:ea typeface="Apple SD Gothic Neo"/>
                 <a:cs typeface="Apple SD Gothic Neo"/>
               </a:rPr>
-              <a:t>9 / 16</a:t>
+              <a:t>9 / 17</a:t>
             </a:r>
           </a:p>
         </p:txBody>

</xml_diff>